<commit_message>
Updated internship completion report
</commit_message>
<xml_diff>
--- a/TEAM MEMBERS  PPT/YUVASREE P.pptx
+++ b/TEAM MEMBERS  PPT/YUVASREE P.pptx
@@ -309,7 +309,7 @@
           <a:p>
             <a:fld id="{5BCAD085-E8A6-8845-BD4E-CB4CCA059FC4}" type="datetimeFigureOut">
               <a:rPr lang="en-US" smtClean="0"/>
-              <a:t>8/16/2026</a:t>
+              <a:t>8/20/2026</a:t>
             </a:fld>
             <a:endParaRPr lang="en-US"/>
           </a:p>
@@ -477,7 +477,7 @@
           <a:p>
             <a:fld id="{5BCAD085-E8A6-8845-BD4E-CB4CCA059FC4}" type="datetimeFigureOut">
               <a:rPr lang="en-US" smtClean="0"/>
-              <a:t>8/16/2026</a:t>
+              <a:t>8/20/2026</a:t>
             </a:fld>
             <a:endParaRPr lang="en-US"/>
           </a:p>
@@ -655,7 +655,7 @@
           <a:p>
             <a:fld id="{5BCAD085-E8A6-8845-BD4E-CB4CCA059FC4}" type="datetimeFigureOut">
               <a:rPr lang="en-US" smtClean="0"/>
-              <a:t>8/16/2026</a:t>
+              <a:t>8/20/2026</a:t>
             </a:fld>
             <a:endParaRPr lang="en-US"/>
           </a:p>
@@ -823,7 +823,7 @@
           <a:p>
             <a:fld id="{5BCAD085-E8A6-8845-BD4E-CB4CCA059FC4}" type="datetimeFigureOut">
               <a:rPr lang="en-US" smtClean="0"/>
-              <a:t>8/16/2026</a:t>
+              <a:t>8/20/2026</a:t>
             </a:fld>
             <a:endParaRPr lang="en-US"/>
           </a:p>
@@ -1068,7 +1068,7 @@
           <a:p>
             <a:fld id="{5BCAD085-E8A6-8845-BD4E-CB4CCA059FC4}" type="datetimeFigureOut">
               <a:rPr lang="en-US" smtClean="0"/>
-              <a:t>8/16/2026</a:t>
+              <a:t>8/20/2026</a:t>
             </a:fld>
             <a:endParaRPr lang="en-US"/>
           </a:p>
@@ -1353,7 +1353,7 @@
           <a:p>
             <a:fld id="{5BCAD085-E8A6-8845-BD4E-CB4CCA059FC4}" type="datetimeFigureOut">
               <a:rPr lang="en-US" smtClean="0"/>
-              <a:t>8/16/2026</a:t>
+              <a:t>8/20/2026</a:t>
             </a:fld>
             <a:endParaRPr lang="en-US"/>
           </a:p>
@@ -1772,7 +1772,7 @@
           <a:p>
             <a:fld id="{5BCAD085-E8A6-8845-BD4E-CB4CCA059FC4}" type="datetimeFigureOut">
               <a:rPr lang="en-US" smtClean="0"/>
-              <a:t>8/16/2026</a:t>
+              <a:t>8/20/2026</a:t>
             </a:fld>
             <a:endParaRPr lang="en-US"/>
           </a:p>
@@ -1889,7 +1889,7 @@
           <a:p>
             <a:fld id="{5BCAD085-E8A6-8845-BD4E-CB4CCA059FC4}" type="datetimeFigureOut">
               <a:rPr lang="en-US" smtClean="0"/>
-              <a:t>8/16/2026</a:t>
+              <a:t>8/20/2026</a:t>
             </a:fld>
             <a:endParaRPr lang="en-US"/>
           </a:p>
@@ -1984,7 +1984,7 @@
           <a:p>
             <a:fld id="{5BCAD085-E8A6-8845-BD4E-CB4CCA059FC4}" type="datetimeFigureOut">
               <a:rPr lang="en-US" smtClean="0"/>
-              <a:t>8/16/2026</a:t>
+              <a:t>8/20/2026</a:t>
             </a:fld>
             <a:endParaRPr lang="en-US"/>
           </a:p>
@@ -2259,7 +2259,7 @@
           <a:p>
             <a:fld id="{5BCAD085-E8A6-8845-BD4E-CB4CCA059FC4}" type="datetimeFigureOut">
               <a:rPr lang="en-US" smtClean="0"/>
-              <a:t>8/16/2026</a:t>
+              <a:t>8/20/2026</a:t>
             </a:fld>
             <a:endParaRPr lang="en-US"/>
           </a:p>
@@ -2511,7 +2511,7 @@
           <a:p>
             <a:fld id="{5BCAD085-E8A6-8845-BD4E-CB4CCA059FC4}" type="datetimeFigureOut">
               <a:rPr lang="en-US" smtClean="0"/>
-              <a:t>8/16/2026</a:t>
+              <a:t>8/20/2026</a:t>
             </a:fld>
             <a:endParaRPr lang="en-US"/>
           </a:p>
@@ -2722,7 +2722,7 @@
           <a:p>
             <a:fld id="{5BCAD085-E8A6-8845-BD4E-CB4CCA059FC4}" type="datetimeFigureOut">
               <a:rPr lang="en-US" smtClean="0"/>
-              <a:t>8/16/2026</a:t>
+              <a:t>8/20/2026</a:t>
             </a:fld>
             <a:endParaRPr lang="en-US"/>
           </a:p>
@@ -3326,7 +3326,7 @@
         <p:spPr>
           <a:xfrm>
             <a:off x="713232" y="1325880"/>
-            <a:ext cx="6446520" cy="1325880"/>
+            <a:ext cx="6446520" cy="1877437"/>
           </a:xfrm>
           <a:prstGeom prst="rect">
             <a:avLst/>
@@ -3348,12 +3348,31 @@
               </a:defRPr>
             </a:pPr>
             <a:r>
+              <a:rPr dirty="0"/>
               <a:t>SUPPLY CHAIN VISIBILITY SYSTEM</a:t>
             </a:r>
-            <a:br/>
-            <a:r>
+            <a:br>
+              <a:rPr dirty="0"/>
+            </a:br>
+            <a:r>
+              <a:rPr dirty="0"/>
               <a:t>WITH OPTIMIZATION ANALYTICS</a:t>
             </a:r>
+            <a:r>
+              <a:rPr lang="en-IN" dirty="0"/>
+              <a:t> GROUP 1</a:t>
+            </a:r>
+          </a:p>
+          <a:p>
+            <a:pPr algn="l">
+              <a:defRPr sz="2900" b="1">
+                <a:solidFill>
+                  <a:srgbClr val="FFFFFF"/>
+                </a:solidFill>
+                <a:latin typeface="Aptos Display"/>
+              </a:defRPr>
+            </a:pPr>
+            <a:endParaRPr dirty="0"/>
           </a:p>
         </p:txBody>
       </p:sp>
@@ -3402,7 +3421,7 @@
         <p:spPr>
           <a:xfrm>
             <a:off x="749808" y="3657600"/>
-            <a:ext cx="6263640" cy="830997"/>
+            <a:ext cx="6263640" cy="1569660"/>
           </a:xfrm>
           <a:prstGeom prst="rect">
             <a:avLst/>
@@ -3425,7 +3444,37 @@
             </a:pPr>
             <a:r>
               <a:rPr dirty="0"/>
-              <a:t>Team Members:   Uppala Bhavya Sri | V. Charita Sree</a:t>
+              <a:t>Team Members:   </a:t>
+            </a:r>
+            <a:endParaRPr lang="en-IN" dirty="0"/>
+          </a:p>
+          <a:p>
+            <a:pPr algn="l">
+              <a:defRPr sz="1200" b="0">
+                <a:solidFill>
+                  <a:srgbClr val="FFFFFF"/>
+                </a:solidFill>
+                <a:latin typeface="Aptos Display"/>
+              </a:defRPr>
+            </a:pPr>
+            <a:r>
+              <a:rPr dirty="0"/>
+              <a:t>Uppala Bhavya Sri </a:t>
+            </a:r>
+            <a:endParaRPr lang="en-IN" dirty="0"/>
+          </a:p>
+          <a:p>
+            <a:pPr algn="l">
+              <a:defRPr sz="1200" b="0">
+                <a:solidFill>
+                  <a:srgbClr val="FFFFFF"/>
+                </a:solidFill>
+                <a:latin typeface="Aptos Display"/>
+              </a:defRPr>
+            </a:pPr>
+            <a:r>
+              <a:rPr dirty="0"/>
+              <a:t>V. Charita Sree</a:t>
             </a:r>
             <a:br>
               <a:rPr dirty="0"/>
@@ -3436,7 +3485,37 @@
             </a:r>
             <a:r>
               <a:rPr dirty="0"/>
-              <a:t> Sai Rohitha | Venkata Puneeth Kothapalli | Yuvasree P</a:t>
+              <a:t> Sai Rohitha</a:t>
+            </a:r>
+            <a:endParaRPr lang="en-IN" dirty="0"/>
+          </a:p>
+          <a:p>
+            <a:pPr algn="l">
+              <a:defRPr sz="1200" b="0">
+                <a:solidFill>
+                  <a:srgbClr val="FFFFFF"/>
+                </a:solidFill>
+                <a:latin typeface="Aptos Display"/>
+              </a:defRPr>
+            </a:pPr>
+            <a:r>
+              <a:rPr dirty="0"/>
+              <a:t> |Venkata Puneeth Kothapalli |</a:t>
+            </a:r>
+            <a:endParaRPr lang="en-IN" dirty="0"/>
+          </a:p>
+          <a:p>
+            <a:pPr algn="l">
+              <a:defRPr sz="1200" b="0">
+                <a:solidFill>
+                  <a:srgbClr val="FFFFFF"/>
+                </a:solidFill>
+                <a:latin typeface="Aptos Display"/>
+              </a:defRPr>
+            </a:pPr>
+            <a:r>
+              <a:rPr dirty="0"/>
+              <a:t>Yuvasree P</a:t>
             </a:r>
             <a:br>
               <a:rPr dirty="0"/>
@@ -7246,7 +7325,7 @@
                 <a:spcPts val="500"/>
               </a:spcAft>
             </a:pPr>
-            <a:endParaRPr/>
+            <a:endParaRPr dirty="0"/>
           </a:p>
         </p:txBody>
       </p:sp>
@@ -7529,8 +7608,8 @@
         </p:nvSpPr>
         <p:spPr>
           <a:xfrm>
-            <a:off x="914400" y="1874519"/>
-            <a:ext cx="4617720" cy="2043123"/>
+            <a:off x="914398" y="1874519"/>
+            <a:ext cx="4824000" cy="3231654"/>
           </a:xfrm>
           <a:prstGeom prst="rect">
             <a:avLst/>
@@ -7543,148 +7622,71 @@
           </a:bodyPr>
           <a:lstStyle/>
           <a:p>
-            <a:pPr>
-              <a:spcAft>
-                <a:spcPts val="500"/>
-              </a:spcAft>
-              <a:defRPr sz="1220">
-                <a:solidFill>
-                  <a:srgbClr val="19191E"/>
-                </a:solidFill>
-                <a:latin typeface="Aptos"/>
-              </a:defRPr>
-            </a:pPr>
-            <a:r>
-              <a:rPr dirty="0"/>
-              <a:t>• Infosys Springboard – Virtual Internship 7.0</a:t>
-            </a:r>
-          </a:p>
-          <a:p>
-            <a:pPr>
-              <a:spcAft>
-                <a:spcPts val="500"/>
-              </a:spcAft>
-              <a:defRPr sz="1220">
-                <a:solidFill>
-                  <a:srgbClr val="19191E"/>
-                </a:solidFill>
-                <a:latin typeface="Aptos"/>
-              </a:defRPr>
-            </a:pPr>
-            <a:r>
-              <a:rPr dirty="0"/>
-              <a:t>• Mentor – Ms. Nityasree</a:t>
-            </a:r>
-          </a:p>
-          <a:p>
-            <a:pPr>
-              <a:spcAft>
-                <a:spcPts val="500"/>
-              </a:spcAft>
-              <a:defRPr sz="1220">
-                <a:solidFill>
-                  <a:srgbClr val="19191E"/>
-                </a:solidFill>
-                <a:latin typeface="Aptos"/>
-              </a:defRPr>
-            </a:pPr>
-            <a:r>
-              <a:rPr dirty="0"/>
-              <a:t>• Team D – Group 1</a:t>
-            </a:r>
-          </a:p>
-          <a:p>
-            <a:pPr>
-              <a:spcAft>
-                <a:spcPts val="500"/>
-              </a:spcAft>
-              <a:defRPr sz="1220">
-                <a:solidFill>
-                  <a:srgbClr val="19191E"/>
-                </a:solidFill>
-                <a:latin typeface="Aptos"/>
-              </a:defRPr>
-            </a:pPr>
-            <a:r>
-              <a:rPr dirty="0"/>
-              <a:t>• Uppala Bhavya Sri</a:t>
-            </a:r>
-          </a:p>
-          <a:p>
-            <a:pPr>
-              <a:spcAft>
-                <a:spcPts val="500"/>
-              </a:spcAft>
-              <a:defRPr sz="1220">
-                <a:solidFill>
-                  <a:srgbClr val="19191E"/>
-                </a:solidFill>
-                <a:latin typeface="Aptos"/>
-              </a:defRPr>
-            </a:pPr>
-            <a:r>
-              <a:rPr dirty="0"/>
-              <a:t>• V. Charita Sree</a:t>
-            </a:r>
-          </a:p>
-          <a:p>
-            <a:pPr>
-              <a:spcAft>
-                <a:spcPts val="500"/>
-              </a:spcAft>
-              <a:defRPr sz="1220">
-                <a:solidFill>
-                  <a:srgbClr val="19191E"/>
-                </a:solidFill>
-                <a:latin typeface="Aptos"/>
-              </a:defRPr>
-            </a:pPr>
-            <a:r>
-              <a:rPr dirty="0"/>
-              <a:t>• </a:t>
-            </a:r>
-            <a:r>
-              <a:rPr dirty="0" err="1"/>
-              <a:t>Velpuri</a:t>
-            </a:r>
-            <a:r>
-              <a:rPr dirty="0"/>
-              <a:t> Sai Rohitha</a:t>
-            </a:r>
-          </a:p>
-          <a:p>
-            <a:pPr>
-              <a:spcAft>
-                <a:spcPts val="500"/>
-              </a:spcAft>
-              <a:defRPr sz="1220">
-                <a:solidFill>
-                  <a:srgbClr val="19191E"/>
-                </a:solidFill>
-                <a:latin typeface="Aptos"/>
-              </a:defRPr>
-            </a:pPr>
-            <a:r>
-              <a:rPr dirty="0"/>
-              <a:t>• Venkata Puneeth Kothapalli</a:t>
-            </a:r>
-          </a:p>
-          <a:p>
-            <a:pPr>
-              <a:spcAft>
-                <a:spcPts val="500"/>
-              </a:spcAft>
-              <a:defRPr sz="1220">
-                <a:solidFill>
-                  <a:srgbClr val="19191E"/>
-                </a:solidFill>
-                <a:latin typeface="Aptos"/>
-              </a:defRPr>
-            </a:pPr>
-            <a:r>
-              <a:rPr dirty="0"/>
-              <a:t>• Yuvasree P</a:t>
-            </a:r>
+            <a:pPr marL="171450" indent="-171450">
+              <a:buFont typeface="Arial" panose="020B0604020202020204" pitchFamily="34" charset="0"/>
+              <a:buChar char="•"/>
+            </a:pPr>
+            <a:r>
+              <a:rPr lang="en-IN" sz="1200" dirty="0"/>
+              <a:t>  </a:t>
+            </a:r>
+          </a:p>
+          <a:p>
+            <a:pPr marL="171450" indent="-171450">
+              <a:buFont typeface="Arial" panose="020B0604020202020204" pitchFamily="34" charset="0"/>
+              <a:buChar char="•"/>
+            </a:pPr>
+            <a:r>
+              <a:rPr lang="en-IN" sz="1200" dirty="0"/>
+              <a:t>We sincerely thank the Infosys Springboard Team for providing this enriching virtual internship and a structured platform for gaining practical industry experience.</a:t>
+            </a:r>
+          </a:p>
+          <a:p>
+            <a:pPr marL="171450" indent="-171450">
+              <a:buFont typeface="Arial" panose="020B0604020202020204" pitchFamily="34" charset="0"/>
+              <a:buChar char="•"/>
+            </a:pPr>
+            <a:r>
+              <a:rPr lang="en-IN" sz="1200" dirty="0"/>
+              <a:t>We express our heartfelt gratitude to our mentor, Ms. Nityasree, for her continuous guidance, valuable feedback, and encouragement throughout the project.</a:t>
+            </a:r>
+          </a:p>
+          <a:p>
+            <a:pPr marL="171450" indent="-171450">
+              <a:buFont typeface="Arial" panose="020B0604020202020204" pitchFamily="34" charset="0"/>
+              <a:buChar char="•"/>
+            </a:pPr>
+            <a:r>
+              <a:rPr lang="en-IN" sz="1200" dirty="0"/>
+              <a:t>We also thank our team members for their collaboration, communication, and shared efforts in successfully completing the project.</a:t>
+            </a:r>
+          </a:p>
+          <a:p>
+            <a:pPr marL="171450" indent="-171450">
+              <a:buFont typeface="Arial" panose="020B0604020202020204" pitchFamily="34" charset="0"/>
+              <a:buChar char="•"/>
+            </a:pPr>
+            <a:r>
+              <a:rPr lang="en-IN" sz="1200" dirty="0"/>
+              <a:t>We acknowledge Microsoft Power BI documentation and community resources, along with Kaggle, for providing valuable learning resources and datasets that supported our dashboard development and analysis.</a:t>
+            </a:r>
+          </a:p>
+          <a:p>
+            <a:pPr marL="171450" indent="-171450">
+              <a:buFont typeface="Arial" panose="020B0604020202020204" pitchFamily="34" charset="0"/>
+              <a:buChar char="•"/>
+            </a:pPr>
+            <a:r>
+              <a:rPr lang="en-IN" sz="1200" dirty="0"/>
+              <a:t>Overall, this internship strengthened our technical, analytical, teamwork, and problem-solving skills and provided valuable practical experience in data-driven decision-making.</a:t>
+            </a:r>
+          </a:p>
+          <a:p>
+            <a:pPr marL="171450" indent="-171450" algn="just">
+              <a:buFont typeface="Arial" panose="020B0604020202020204" pitchFamily="34" charset="0"/>
+              <a:buChar char="•"/>
+            </a:pPr>
+            <a:endParaRPr lang="en-US" sz="1200" dirty="0"/>
           </a:p>
         </p:txBody>
       </p:sp>

</xml_diff>

<commit_message>
All files are updated
</commit_message>
<xml_diff>
--- a/TEAM MEMBERS  PPT/YUVASREE P.pptx
+++ b/TEAM MEMBERS  PPT/YUVASREE P.pptx
@@ -309,7 +309,7 @@
           <a:p>
             <a:fld id="{5BCAD085-E8A6-8845-BD4E-CB4CCA059FC4}" type="datetimeFigureOut">
               <a:rPr lang="en-US" smtClean="0"/>
-              <a:t>8/20/2026</a:t>
+              <a:t>8/26/2026</a:t>
             </a:fld>
             <a:endParaRPr lang="en-US"/>
           </a:p>
@@ -477,7 +477,7 @@
           <a:p>
             <a:fld id="{5BCAD085-E8A6-8845-BD4E-CB4CCA059FC4}" type="datetimeFigureOut">
               <a:rPr lang="en-US" smtClean="0"/>
-              <a:t>8/20/2026</a:t>
+              <a:t>8/26/2026</a:t>
             </a:fld>
             <a:endParaRPr lang="en-US"/>
           </a:p>
@@ -655,7 +655,7 @@
           <a:p>
             <a:fld id="{5BCAD085-E8A6-8845-BD4E-CB4CCA059FC4}" type="datetimeFigureOut">
               <a:rPr lang="en-US" smtClean="0"/>
-              <a:t>8/20/2026</a:t>
+              <a:t>8/26/2026</a:t>
             </a:fld>
             <a:endParaRPr lang="en-US"/>
           </a:p>
@@ -823,7 +823,7 @@
           <a:p>
             <a:fld id="{5BCAD085-E8A6-8845-BD4E-CB4CCA059FC4}" type="datetimeFigureOut">
               <a:rPr lang="en-US" smtClean="0"/>
-              <a:t>8/20/2026</a:t>
+              <a:t>8/26/2026</a:t>
             </a:fld>
             <a:endParaRPr lang="en-US"/>
           </a:p>
@@ -1068,7 +1068,7 @@
           <a:p>
             <a:fld id="{5BCAD085-E8A6-8845-BD4E-CB4CCA059FC4}" type="datetimeFigureOut">
               <a:rPr lang="en-US" smtClean="0"/>
-              <a:t>8/20/2026</a:t>
+              <a:t>8/26/2026</a:t>
             </a:fld>
             <a:endParaRPr lang="en-US"/>
           </a:p>
@@ -1353,7 +1353,7 @@
           <a:p>
             <a:fld id="{5BCAD085-E8A6-8845-BD4E-CB4CCA059FC4}" type="datetimeFigureOut">
               <a:rPr lang="en-US" smtClean="0"/>
-              <a:t>8/20/2026</a:t>
+              <a:t>8/26/2026</a:t>
             </a:fld>
             <a:endParaRPr lang="en-US"/>
           </a:p>
@@ -1772,7 +1772,7 @@
           <a:p>
             <a:fld id="{5BCAD085-E8A6-8845-BD4E-CB4CCA059FC4}" type="datetimeFigureOut">
               <a:rPr lang="en-US" smtClean="0"/>
-              <a:t>8/20/2026</a:t>
+              <a:t>8/26/2026</a:t>
             </a:fld>
             <a:endParaRPr lang="en-US"/>
           </a:p>
@@ -1889,7 +1889,7 @@
           <a:p>
             <a:fld id="{5BCAD085-E8A6-8845-BD4E-CB4CCA059FC4}" type="datetimeFigureOut">
               <a:rPr lang="en-US" smtClean="0"/>
-              <a:t>8/20/2026</a:t>
+              <a:t>8/26/2026</a:t>
             </a:fld>
             <a:endParaRPr lang="en-US"/>
           </a:p>
@@ -1984,7 +1984,7 @@
           <a:p>
             <a:fld id="{5BCAD085-E8A6-8845-BD4E-CB4CCA059FC4}" type="datetimeFigureOut">
               <a:rPr lang="en-US" smtClean="0"/>
-              <a:t>8/20/2026</a:t>
+              <a:t>8/26/2026</a:t>
             </a:fld>
             <a:endParaRPr lang="en-US"/>
           </a:p>
@@ -2259,7 +2259,7 @@
           <a:p>
             <a:fld id="{5BCAD085-E8A6-8845-BD4E-CB4CCA059FC4}" type="datetimeFigureOut">
               <a:rPr lang="en-US" smtClean="0"/>
-              <a:t>8/20/2026</a:t>
+              <a:t>8/26/2026</a:t>
             </a:fld>
             <a:endParaRPr lang="en-US"/>
           </a:p>
@@ -2511,7 +2511,7 @@
           <a:p>
             <a:fld id="{5BCAD085-E8A6-8845-BD4E-CB4CCA059FC4}" type="datetimeFigureOut">
               <a:rPr lang="en-US" smtClean="0"/>
-              <a:t>8/20/2026</a:t>
+              <a:t>8/26/2026</a:t>
             </a:fld>
             <a:endParaRPr lang="en-US"/>
           </a:p>
@@ -2722,7 +2722,7 @@
           <a:p>
             <a:fld id="{5BCAD085-E8A6-8845-BD4E-CB4CCA059FC4}" type="datetimeFigureOut">
               <a:rPr lang="en-US" smtClean="0"/>
-              <a:t>8/20/2026</a:t>
+              <a:t>8/26/2026</a:t>
             </a:fld>
             <a:endParaRPr lang="en-US"/>
           </a:p>
@@ -4743,30 +4743,6 @@
           </a:p>
         </p:txBody>
       </p:sp>
-      <p:pic>
-        <p:nvPicPr>
-          <p:cNvPr id="6" name="Picture 5" descr="workflow.png"/>
-          <p:cNvPicPr>
-            <a:picLocks noChangeAspect="1"/>
-          </p:cNvPicPr>
-          <p:nvPr/>
-        </p:nvPicPr>
-        <p:blipFill>
-          <a:blip r:embed="rId2"/>
-          <a:stretch>
-            <a:fillRect/>
-          </a:stretch>
-        </p:blipFill>
-        <p:spPr>
-          <a:xfrm>
-            <a:off x="594360" y="1143000"/>
-            <a:ext cx="5212080" cy="3017520"/>
-          </a:xfrm>
-          <a:prstGeom prst="rect">
-            <a:avLst/>
-          </a:prstGeom>
-        </p:spPr>
-      </p:pic>
       <p:sp>
         <p:nvSpPr>
           <p:cNvPr id="7" name="TextBox 6"/>
@@ -4845,12 +4821,28 @@
               </a:defRPr>
             </a:pPr>
             <a:r>
-              <a:rPr>
+              <a:rPr dirty="0">
                 <a:solidFill>
                   <a:srgbClr val="19191E"/>
                 </a:solidFill>
               </a:rPr>
-              <a:t>Studied the DataCoSupplyChainDataset and prepared the data using Power Query.</a:t>
+              <a:t>Studied the </a:t>
+            </a:r>
+            <a:r>
+              <a:rPr dirty="0" err="1">
+                <a:solidFill>
+                  <a:srgbClr val="19191E"/>
+                </a:solidFill>
+              </a:rPr>
+              <a:t>DataCoSupplyChainDataset</a:t>
+            </a:r>
+            <a:r>
+              <a:rPr dirty="0">
+                <a:solidFill>
+                  <a:srgbClr val="19191E"/>
+                </a:solidFill>
+              </a:rPr>
+              <a:t> and prepared the data using Power Query.</a:t>
             </a:r>
           </a:p>
         </p:txBody>
@@ -5116,6 +5108,2182 @@
               </a:rPr>
               <a:t>Validated calculations and improved dashboard readability, consistency and usability.</a:t>
             </a:r>
+          </a:p>
+        </p:txBody>
+      </p:sp>
+      <p:sp>
+        <p:nvSpPr>
+          <p:cNvPr id="15" name="TextBox 14">
+            <a:extLst>
+              <a:ext uri="{FF2B5EF4-FFF2-40B4-BE49-F238E27FC236}">
+                <a16:creationId xmlns:a16="http://schemas.microsoft.com/office/drawing/2014/main" id="{67D35489-45DF-6CA9-0A23-C5D47DCB6CFF}"/>
+              </a:ext>
+            </a:extLst>
+          </p:cNvPr>
+          <p:cNvSpPr txBox="1"/>
+          <p:nvPr/>
+        </p:nvSpPr>
+        <p:spPr>
+          <a:xfrm>
+            <a:off x="4769443" y="-391851"/>
+            <a:ext cx="4727714" cy="253916"/>
+          </a:xfrm>
+          <a:prstGeom prst="rect">
+            <a:avLst/>
+          </a:prstGeom>
+          <a:noFill/>
+        </p:spPr>
+        <p:txBody>
+          <a:bodyPr wrap="square">
+            <a:spAutoFit/>
+          </a:bodyPr>
+          <a:lstStyle/>
+          <a:p>
+            <a:pPr algn="ctr"/>
+            <a:r>
+              <a:rPr lang="en-IN" sz="1050" b="1" dirty="0">
+                <a:solidFill>
+                  <a:srgbClr val="0A1C30"/>
+                </a:solidFill>
+                <a:latin typeface="Aptos"/>
+              </a:rPr>
+              <a:t> </a:t>
+            </a:r>
+          </a:p>
+        </p:txBody>
+      </p:sp>
+      <p:sp>
+        <p:nvSpPr>
+          <p:cNvPr id="17" name="Rectangle 34">
+            <a:extLst>
+              <a:ext uri="{FF2B5EF4-FFF2-40B4-BE49-F238E27FC236}">
+                <a16:creationId xmlns:a16="http://schemas.microsoft.com/office/drawing/2014/main" id="{0C1B7D9F-6810-B7DC-A3F6-58CE21181857}"/>
+              </a:ext>
+            </a:extLst>
+          </p:cNvPr>
+          <p:cNvSpPr>
+            <a:spLocks noChangeArrowheads="1"/>
+          </p:cNvSpPr>
+          <p:nvPr/>
+        </p:nvSpPr>
+        <p:spPr bwMode="auto">
+          <a:xfrm>
+            <a:off x="2996857" y="-2451610"/>
+            <a:ext cx="1210818" cy="1092889"/>
+          </a:xfrm>
+          <a:prstGeom prst="rect">
+            <a:avLst/>
+          </a:prstGeom>
+          <a:noFill/>
+          <a:ln>
+            <a:noFill/>
+          </a:ln>
+          <a:effectLst/>
+          <a:extLst>
+            <a:ext uri="{909E8E84-426E-40DD-AFC4-6F175D3DCCD1}">
+              <a14:hiddenFill xmlns:a14="http://schemas.microsoft.com/office/drawing/2010/main">
+                <a:solidFill>
+                  <a:schemeClr val="accent1"/>
+                </a:solidFill>
+              </a14:hiddenFill>
+            </a:ext>
+            <a:ext uri="{91240B29-F687-4F45-9708-019B960494DF}">
+              <a14:hiddenLine xmlns:a14="http://schemas.microsoft.com/office/drawing/2010/main" w="9525">
+                <a:solidFill>
+                  <a:schemeClr val="tx1"/>
+                </a:solidFill>
+                <a:miter lim="800000"/>
+                <a:headEnd/>
+                <a:tailEnd/>
+              </a14:hiddenLine>
+            </a:ext>
+            <a:ext uri="{AF507438-7753-43E0-B8FC-AC1667EBCBE1}">
+              <a14:hiddenEffects xmlns:a14="http://schemas.microsoft.com/office/drawing/2010/main">
+                <a:effectLst>
+                  <a:outerShdw dist="35921" dir="2700000" algn="ctr" rotWithShape="0">
+                    <a:schemeClr val="bg2"/>
+                  </a:outerShdw>
+                </a:effectLst>
+              </a14:hiddenEffects>
+            </a:ext>
+          </a:extLst>
+        </p:spPr>
+        <p:txBody>
+          <a:bodyPr vert="horz" wrap="square" lIns="228528" tIns="122199" rIns="91440" bIns="0" numCol="1" anchor="ctr" anchorCtr="0" compatLnSpc="1">
+            <a:prstTxWarp prst="textNoShape">
+              <a:avLst/>
+            </a:prstTxWarp>
+            <a:spAutoFit/>
+          </a:bodyPr>
+          <a:lstStyle/>
+          <a:p>
+            <a:pPr marL="0" marR="0" lvl="0" indent="0" algn="l" defTabSz="914400" rtl="0" eaLnBrk="0" fontAlgn="base" latinLnBrk="0" hangingPunct="0">
+              <a:lnSpc>
+                <a:spcPct val="100000"/>
+              </a:lnSpc>
+              <a:spcBef>
+                <a:spcPct val="0"/>
+              </a:spcBef>
+              <a:spcAft>
+                <a:spcPct val="0"/>
+              </a:spcAft>
+              <a:buClrTx/>
+              <a:buSzTx/>
+              <a:buFontTx/>
+              <a:buNone/>
+              <a:tabLst/>
+            </a:pPr>
+            <a:r>
+              <a:rPr kumimoji="0" lang="en-US" altLang="en-US" sz="1050" b="1" i="0" u="none" strike="noStrike" cap="none" normalizeH="0" baseline="0">
+                <a:ln>
+                  <a:noFill/>
+                </a:ln>
+                <a:solidFill>
+                  <a:schemeClr val="tx1"/>
+                </a:solidFill>
+                <a:effectLst/>
+                <a:latin typeface="Arial" panose="020B0604020202020204" pitchFamily="34" charset="0"/>
+                <a:ea typeface="Arial" panose="020B0604020202020204" pitchFamily="34" charset="0"/>
+              </a:rPr>
+              <a:t>Project Execution Details</a:t>
+            </a:r>
+          </a:p>
+          <a:p>
+            <a:pPr marL="0" marR="0" lvl="0" indent="0" algn="l" defTabSz="914400" rtl="0" eaLnBrk="0" fontAlgn="base" latinLnBrk="0" hangingPunct="0">
+              <a:lnSpc>
+                <a:spcPct val="100000"/>
+              </a:lnSpc>
+              <a:spcBef>
+                <a:spcPct val="0"/>
+              </a:spcBef>
+              <a:spcAft>
+                <a:spcPct val="0"/>
+              </a:spcAft>
+              <a:buClrTx/>
+              <a:buSzTx/>
+              <a:buFontTx/>
+              <a:buNone/>
+              <a:tabLst/>
+            </a:pPr>
+            <a:r>
+              <a:rPr kumimoji="0" lang="en-US" altLang="en-US" sz="1050" b="1" i="0" u="none" strike="noStrike" cap="none" normalizeH="0" baseline="0">
+                <a:ln>
+                  <a:noFill/>
+                </a:ln>
+                <a:solidFill>
+                  <a:schemeClr val="tx1"/>
+                </a:solidFill>
+                <a:effectLst/>
+                <a:latin typeface="Arial" panose="020B0604020202020204" pitchFamily="34" charset="0"/>
+                <a:ea typeface="Arial" panose="020B0604020202020204" pitchFamily="34" charset="0"/>
+              </a:rPr>
+              <a:t>WORKFLOW DIAGRAM</a:t>
+            </a:r>
+          </a:p>
+          <a:p>
+            <a:pPr marL="0" marR="0" lvl="0" indent="0" algn="l" defTabSz="914400" rtl="0" eaLnBrk="0" fontAlgn="base" latinLnBrk="0" hangingPunct="0">
+              <a:lnSpc>
+                <a:spcPct val="100000"/>
+              </a:lnSpc>
+              <a:spcBef>
+                <a:spcPct val="0"/>
+              </a:spcBef>
+              <a:spcAft>
+                <a:spcPct val="0"/>
+              </a:spcAft>
+              <a:buClrTx/>
+              <a:buSzTx/>
+              <a:buFontTx/>
+              <a:buNone/>
+              <a:tabLst/>
+            </a:pPr>
+            <a:endParaRPr kumimoji="0" lang="en-US" altLang="en-US" sz="1050" b="0" i="0" u="none" strike="noStrike" cap="none" normalizeH="0" baseline="0">
+              <a:ln>
+                <a:noFill/>
+              </a:ln>
+              <a:solidFill>
+                <a:schemeClr val="tx1"/>
+              </a:solidFill>
+              <a:effectLst/>
+              <a:latin typeface="Arial" panose="020B0604020202020204" pitchFamily="34" charset="0"/>
+            </a:endParaRPr>
+          </a:p>
+        </p:txBody>
+      </p:sp>
+      <p:grpSp>
+        <p:nvGrpSpPr>
+          <p:cNvPr id="18" name="Group 17">
+            <a:extLst>
+              <a:ext uri="{FF2B5EF4-FFF2-40B4-BE49-F238E27FC236}">
+                <a16:creationId xmlns:a16="http://schemas.microsoft.com/office/drawing/2014/main" id="{0885C3FD-072C-53B6-C68E-595BED4A95D9}"/>
+              </a:ext>
+            </a:extLst>
+          </p:cNvPr>
+          <p:cNvGrpSpPr>
+            <a:grpSpLocks/>
+          </p:cNvGrpSpPr>
+          <p:nvPr/>
+        </p:nvGrpSpPr>
+        <p:grpSpPr>
+          <a:xfrm>
+            <a:off x="1121671" y="1297768"/>
+            <a:ext cx="3086003" cy="5151189"/>
+            <a:chOff x="-91504" y="66734"/>
+            <a:chExt cx="3212529" cy="7133404"/>
+          </a:xfrm>
+        </p:grpSpPr>
+        <p:sp>
+          <p:nvSpPr>
+            <p:cNvPr id="19" name="Graphic 19">
+              <a:extLst>
+                <a:ext uri="{FF2B5EF4-FFF2-40B4-BE49-F238E27FC236}">
+                  <a16:creationId xmlns:a16="http://schemas.microsoft.com/office/drawing/2014/main" id="{B97F6697-52EF-89E1-26DF-5BA605C2484E}"/>
+                </a:ext>
+              </a:extLst>
+            </p:cNvPr>
+            <p:cNvSpPr/>
+            <p:nvPr/>
+          </p:nvSpPr>
+          <p:spPr>
+            <a:xfrm>
+              <a:off x="-91504" y="6833109"/>
+              <a:ext cx="3089275" cy="367029"/>
+            </a:xfrm>
+            <a:custGeom>
+              <a:avLst/>
+              <a:gdLst/>
+              <a:ahLst/>
+              <a:cxnLst/>
+              <a:rect l="l" t="t" r="r" b="b"/>
+              <a:pathLst>
+                <a:path w="3089275" h="367030">
+                  <a:moveTo>
+                    <a:pt x="0" y="367030"/>
+                  </a:moveTo>
+                  <a:lnTo>
+                    <a:pt x="3089275" y="367030"/>
+                  </a:lnTo>
+                  <a:lnTo>
+                    <a:pt x="3089275" y="0"/>
+                  </a:lnTo>
+                  <a:lnTo>
+                    <a:pt x="0" y="0"/>
+                  </a:lnTo>
+                  <a:lnTo>
+                    <a:pt x="0" y="367030"/>
+                  </a:lnTo>
+                  <a:close/>
+                </a:path>
+              </a:pathLst>
+            </a:custGeom>
+            <a:ln w="25400">
+              <a:solidFill>
+                <a:srgbClr val="4F81BB"/>
+              </a:solidFill>
+              <a:prstDash val="solid"/>
+            </a:ln>
+          </p:spPr>
+          <p:txBody>
+            <a:bodyPr wrap="square" lIns="0" tIns="0" rIns="0" bIns="0" rtlCol="0">
+              <a:prstTxWarp prst="textNoShape">
+                <a:avLst/>
+              </a:prstTxWarp>
+              <a:noAutofit/>
+            </a:bodyPr>
+            <a:lstStyle/>
+            <a:p>
+              <a:pPr lvl="2"/>
+              <a:r>
+                <a:rPr lang="en-IN" sz="1200" dirty="0"/>
+                <a:t>Share and Publish</a:t>
+              </a:r>
+            </a:p>
+          </p:txBody>
+        </p:sp>
+        <p:pic>
+          <p:nvPicPr>
+            <p:cNvPr id="20" name="Image 20">
+              <a:extLst>
+                <a:ext uri="{FF2B5EF4-FFF2-40B4-BE49-F238E27FC236}">
+                  <a16:creationId xmlns:a16="http://schemas.microsoft.com/office/drawing/2014/main" id="{24C08AEC-C16C-A53E-253B-579A024876BC}"/>
+                </a:ext>
+              </a:extLst>
+            </p:cNvPr>
+            <p:cNvPicPr/>
+            <p:nvPr/>
+          </p:nvPicPr>
+          <p:blipFill>
+            <a:blip r:embed="rId2" cstate="print"/>
+            <a:stretch>
+              <a:fillRect/>
+            </a:stretch>
+          </p:blipFill>
+          <p:spPr>
+            <a:xfrm>
+              <a:off x="1313136" y="3757137"/>
+              <a:ext cx="168806" cy="509649"/>
+            </a:xfrm>
+            <a:prstGeom prst="rect">
+              <a:avLst/>
+            </a:prstGeom>
+          </p:spPr>
+        </p:pic>
+        <p:pic>
+          <p:nvPicPr>
+            <p:cNvPr id="21" name="Image 21">
+              <a:extLst>
+                <a:ext uri="{FF2B5EF4-FFF2-40B4-BE49-F238E27FC236}">
+                  <a16:creationId xmlns:a16="http://schemas.microsoft.com/office/drawing/2014/main" id="{55E565D0-AFA0-F354-A117-8FB549334A1E}"/>
+                </a:ext>
+              </a:extLst>
+            </p:cNvPr>
+            <p:cNvPicPr/>
+            <p:nvPr/>
+          </p:nvPicPr>
+          <p:blipFill>
+            <a:blip r:embed="rId3" cstate="print"/>
+            <a:stretch>
+              <a:fillRect/>
+            </a:stretch>
+          </p:blipFill>
+          <p:spPr>
+            <a:xfrm>
+              <a:off x="1340103" y="4102227"/>
+              <a:ext cx="114300" cy="115570"/>
+            </a:xfrm>
+            <a:prstGeom prst="rect">
+              <a:avLst/>
+            </a:prstGeom>
+          </p:spPr>
+        </p:pic>
+        <p:sp>
+          <p:nvSpPr>
+            <p:cNvPr id="22" name="Graphic 22">
+              <a:extLst>
+                <a:ext uri="{FF2B5EF4-FFF2-40B4-BE49-F238E27FC236}">
+                  <a16:creationId xmlns:a16="http://schemas.microsoft.com/office/drawing/2014/main" id="{A5E2EC19-993F-B572-0221-A432B55394B9}"/>
+                </a:ext>
+              </a:extLst>
+            </p:cNvPr>
+            <p:cNvSpPr/>
+            <p:nvPr/>
+          </p:nvSpPr>
+          <p:spPr>
+            <a:xfrm>
+              <a:off x="1371091" y="3767201"/>
+              <a:ext cx="45720" cy="337185"/>
+            </a:xfrm>
+            <a:custGeom>
+              <a:avLst/>
+              <a:gdLst/>
+              <a:ahLst/>
+              <a:cxnLst/>
+              <a:rect l="l" t="t" r="r" b="b"/>
+              <a:pathLst>
+                <a:path w="45720" h="337185">
+                  <a:moveTo>
+                    <a:pt x="38100" y="0"/>
+                  </a:moveTo>
+                  <a:lnTo>
+                    <a:pt x="0" y="762"/>
+                  </a:lnTo>
+                  <a:lnTo>
+                    <a:pt x="7112" y="336677"/>
+                  </a:lnTo>
+                  <a:lnTo>
+                    <a:pt x="45212" y="335788"/>
+                  </a:lnTo>
+                  <a:lnTo>
+                    <a:pt x="38100" y="0"/>
+                  </a:lnTo>
+                  <a:close/>
+                </a:path>
+              </a:pathLst>
+            </a:custGeom>
+            <a:solidFill>
+              <a:srgbClr val="4F81BB"/>
+            </a:solidFill>
+          </p:spPr>
+          <p:txBody>
+            <a:bodyPr wrap="square" lIns="0" tIns="0" rIns="0" bIns="0" rtlCol="0">
+              <a:prstTxWarp prst="textNoShape">
+                <a:avLst/>
+              </a:prstTxWarp>
+              <a:noAutofit/>
+            </a:bodyPr>
+            <a:lstStyle/>
+            <a:p>
+              <a:endParaRPr lang="en-IN" sz="1050"/>
+            </a:p>
+          </p:txBody>
+        </p:sp>
+        <p:pic>
+          <p:nvPicPr>
+            <p:cNvPr id="23" name="Image 23">
+              <a:extLst>
+                <a:ext uri="{FF2B5EF4-FFF2-40B4-BE49-F238E27FC236}">
+                  <a16:creationId xmlns:a16="http://schemas.microsoft.com/office/drawing/2014/main" id="{922D5BA7-BDB6-DBAC-FCAF-A659B953ED6D}"/>
+                </a:ext>
+              </a:extLst>
+            </p:cNvPr>
+            <p:cNvPicPr/>
+            <p:nvPr/>
+          </p:nvPicPr>
+          <p:blipFill>
+            <a:blip r:embed="rId4" cstate="print"/>
+            <a:stretch>
+              <a:fillRect/>
+            </a:stretch>
+          </p:blipFill>
+          <p:spPr>
+            <a:xfrm>
+              <a:off x="1163319" y="6214719"/>
+              <a:ext cx="310959" cy="736092"/>
+            </a:xfrm>
+            <a:prstGeom prst="rect">
+              <a:avLst/>
+            </a:prstGeom>
+          </p:spPr>
+        </p:pic>
+        <p:pic>
+          <p:nvPicPr>
+            <p:cNvPr id="24" name="Image 24">
+              <a:extLst>
+                <a:ext uri="{FF2B5EF4-FFF2-40B4-BE49-F238E27FC236}">
+                  <a16:creationId xmlns:a16="http://schemas.microsoft.com/office/drawing/2014/main" id="{8400BF31-DA2C-628D-A469-159988A43182}"/>
+                </a:ext>
+              </a:extLst>
+            </p:cNvPr>
+            <p:cNvPicPr/>
+            <p:nvPr/>
+          </p:nvPicPr>
+          <p:blipFill>
+            <a:blip r:embed="rId5" cstate="print"/>
+            <a:stretch>
+              <a:fillRect/>
+            </a:stretch>
+          </p:blipFill>
+          <p:spPr>
+            <a:xfrm>
+              <a:off x="1262252" y="6659550"/>
+              <a:ext cx="114300" cy="114960"/>
+            </a:xfrm>
+            <a:prstGeom prst="rect">
+              <a:avLst/>
+            </a:prstGeom>
+          </p:spPr>
+        </p:pic>
+        <p:sp>
+          <p:nvSpPr>
+            <p:cNvPr id="25" name="Graphic 25">
+              <a:extLst>
+                <a:ext uri="{FF2B5EF4-FFF2-40B4-BE49-F238E27FC236}">
+                  <a16:creationId xmlns:a16="http://schemas.microsoft.com/office/drawing/2014/main" id="{ACC119DB-1463-34BB-7712-EEA0B33B85E1}"/>
+                </a:ext>
+              </a:extLst>
+            </p:cNvPr>
+            <p:cNvSpPr/>
+            <p:nvPr/>
+          </p:nvSpPr>
+          <p:spPr>
+            <a:xfrm>
+              <a:off x="1295400" y="6233921"/>
+              <a:ext cx="43180" cy="426720"/>
+            </a:xfrm>
+            <a:custGeom>
+              <a:avLst/>
+              <a:gdLst/>
+              <a:ahLst/>
+              <a:cxnLst/>
+              <a:rect l="l" t="t" r="r" b="b"/>
+              <a:pathLst>
+                <a:path w="43180" h="426720">
+                  <a:moveTo>
+                    <a:pt x="38100" y="0"/>
+                  </a:moveTo>
+                  <a:lnTo>
+                    <a:pt x="0" y="507"/>
+                  </a:lnTo>
+                  <a:lnTo>
+                    <a:pt x="4952" y="426516"/>
+                  </a:lnTo>
+                  <a:lnTo>
+                    <a:pt x="43052" y="426072"/>
+                  </a:lnTo>
+                  <a:lnTo>
+                    <a:pt x="38100" y="0"/>
+                  </a:lnTo>
+                  <a:close/>
+                </a:path>
+              </a:pathLst>
+            </a:custGeom>
+            <a:solidFill>
+              <a:srgbClr val="4F81BB"/>
+            </a:solidFill>
+          </p:spPr>
+          <p:txBody>
+            <a:bodyPr wrap="square" lIns="0" tIns="0" rIns="0" bIns="0" rtlCol="0">
+              <a:prstTxWarp prst="textNoShape">
+                <a:avLst/>
+              </a:prstTxWarp>
+              <a:noAutofit/>
+            </a:bodyPr>
+            <a:lstStyle/>
+            <a:p>
+              <a:endParaRPr lang="en-IN" sz="1050"/>
+            </a:p>
+          </p:txBody>
+        </p:sp>
+        <p:pic>
+          <p:nvPicPr>
+            <p:cNvPr id="26" name="Image 26">
+              <a:extLst>
+                <a:ext uri="{FF2B5EF4-FFF2-40B4-BE49-F238E27FC236}">
+                  <a16:creationId xmlns:a16="http://schemas.microsoft.com/office/drawing/2014/main" id="{1E3FBE79-DD1E-D7DF-1F09-208F2ED7C355}"/>
+                </a:ext>
+              </a:extLst>
+            </p:cNvPr>
+            <p:cNvPicPr/>
+            <p:nvPr/>
+          </p:nvPicPr>
+          <p:blipFill>
+            <a:blip r:embed="rId6" cstate="print"/>
+            <a:stretch>
+              <a:fillRect/>
+            </a:stretch>
+          </p:blipFill>
+          <p:spPr>
+            <a:xfrm>
+              <a:off x="1281380" y="4670774"/>
+              <a:ext cx="159922" cy="369441"/>
+            </a:xfrm>
+            <a:prstGeom prst="rect">
+              <a:avLst/>
+            </a:prstGeom>
+          </p:spPr>
+        </p:pic>
+        <p:pic>
+          <p:nvPicPr>
+            <p:cNvPr id="27" name="Image 27">
+              <a:extLst>
+                <a:ext uri="{FF2B5EF4-FFF2-40B4-BE49-F238E27FC236}">
+                  <a16:creationId xmlns:a16="http://schemas.microsoft.com/office/drawing/2014/main" id="{B9D14C60-24A9-E8FD-7A17-D48F1C303334}"/>
+                </a:ext>
+              </a:extLst>
+            </p:cNvPr>
+            <p:cNvPicPr/>
+            <p:nvPr/>
+          </p:nvPicPr>
+          <p:blipFill>
+            <a:blip r:embed="rId7" cstate="print"/>
+            <a:stretch>
+              <a:fillRect/>
+            </a:stretch>
+          </p:blipFill>
+          <p:spPr>
+            <a:xfrm>
+              <a:off x="1306067" y="4680711"/>
+              <a:ext cx="114300" cy="318770"/>
+            </a:xfrm>
+            <a:prstGeom prst="rect">
+              <a:avLst/>
+            </a:prstGeom>
+          </p:spPr>
+        </p:pic>
+        <p:sp>
+          <p:nvSpPr>
+            <p:cNvPr id="28" name="Graphic 28">
+              <a:extLst>
+                <a:ext uri="{FF2B5EF4-FFF2-40B4-BE49-F238E27FC236}">
+                  <a16:creationId xmlns:a16="http://schemas.microsoft.com/office/drawing/2014/main" id="{4DE18EC0-AF51-9C3A-4093-0B5843FBF06F}"/>
+                </a:ext>
+              </a:extLst>
+            </p:cNvPr>
+            <p:cNvSpPr/>
+            <p:nvPr/>
+          </p:nvSpPr>
+          <p:spPr>
+            <a:xfrm>
+              <a:off x="-57597" y="872541"/>
+              <a:ext cx="2955926" cy="2929255"/>
+            </a:xfrm>
+            <a:custGeom>
+              <a:avLst/>
+              <a:gdLst/>
+              <a:ahLst/>
+              <a:cxnLst/>
+              <a:rect l="l" t="t" r="r" b="b"/>
+              <a:pathLst>
+                <a:path w="2955925" h="2929255">
+                  <a:moveTo>
+                    <a:pt x="0" y="325120"/>
+                  </a:moveTo>
+                  <a:lnTo>
+                    <a:pt x="2908935" y="325120"/>
+                  </a:lnTo>
+                  <a:lnTo>
+                    <a:pt x="2908935" y="0"/>
+                  </a:lnTo>
+                  <a:lnTo>
+                    <a:pt x="0" y="0"/>
+                  </a:lnTo>
+                  <a:lnTo>
+                    <a:pt x="0" y="325120"/>
+                  </a:lnTo>
+                  <a:close/>
+                </a:path>
+                <a:path w="2955925" h="2929255">
+                  <a:moveTo>
+                    <a:pt x="20955" y="1260475"/>
+                  </a:moveTo>
+                  <a:lnTo>
+                    <a:pt x="2900680" y="1260475"/>
+                  </a:lnTo>
+                  <a:lnTo>
+                    <a:pt x="2900680" y="824229"/>
+                  </a:lnTo>
+                  <a:lnTo>
+                    <a:pt x="20955" y="824229"/>
+                  </a:lnTo>
+                  <a:lnTo>
+                    <a:pt x="20955" y="1260475"/>
+                  </a:lnTo>
+                  <a:close/>
+                </a:path>
+                <a:path w="2955925" h="2929255">
+                  <a:moveTo>
+                    <a:pt x="34925" y="2063750"/>
+                  </a:moveTo>
+                  <a:lnTo>
+                    <a:pt x="2935605" y="2063750"/>
+                  </a:lnTo>
+                  <a:lnTo>
+                    <a:pt x="2935605" y="1655445"/>
+                  </a:lnTo>
+                  <a:lnTo>
+                    <a:pt x="34925" y="1655445"/>
+                  </a:lnTo>
+                  <a:lnTo>
+                    <a:pt x="34925" y="2063750"/>
+                  </a:lnTo>
+                  <a:close/>
+                </a:path>
+                <a:path w="2955925" h="2929255">
+                  <a:moveTo>
+                    <a:pt x="20955" y="2929254"/>
+                  </a:moveTo>
+                  <a:lnTo>
+                    <a:pt x="2955924" y="2929254"/>
+                  </a:lnTo>
+                  <a:lnTo>
+                    <a:pt x="2955924" y="2541904"/>
+                  </a:lnTo>
+                  <a:lnTo>
+                    <a:pt x="20955" y="2541904"/>
+                  </a:lnTo>
+                  <a:lnTo>
+                    <a:pt x="20955" y="2929254"/>
+                  </a:lnTo>
+                  <a:close/>
+                </a:path>
+              </a:pathLst>
+            </a:custGeom>
+            <a:ln w="25400">
+              <a:solidFill>
+                <a:srgbClr val="4F81BB"/>
+              </a:solidFill>
+              <a:prstDash val="solid"/>
+            </a:ln>
+          </p:spPr>
+          <p:txBody>
+            <a:bodyPr wrap="square" lIns="0" tIns="0" rIns="0" bIns="0" rtlCol="0">
+              <a:prstTxWarp prst="textNoShape">
+                <a:avLst/>
+              </a:prstTxWarp>
+              <a:noAutofit/>
+            </a:bodyPr>
+            <a:lstStyle/>
+            <a:p>
+              <a:endParaRPr lang="en-IN" sz="1050"/>
+            </a:p>
+          </p:txBody>
+        </p:sp>
+        <p:pic>
+          <p:nvPicPr>
+            <p:cNvPr id="29" name="Image 29">
+              <a:extLst>
+                <a:ext uri="{FF2B5EF4-FFF2-40B4-BE49-F238E27FC236}">
+                  <a16:creationId xmlns:a16="http://schemas.microsoft.com/office/drawing/2014/main" id="{9E138972-4AE0-C62A-1597-0C1C7B0FAF31}"/>
+                </a:ext>
+              </a:extLst>
+            </p:cNvPr>
+            <p:cNvPicPr/>
+            <p:nvPr/>
+          </p:nvPicPr>
+          <p:blipFill>
+            <a:blip r:embed="rId8" cstate="print"/>
+            <a:stretch>
+              <a:fillRect/>
+            </a:stretch>
+          </p:blipFill>
+          <p:spPr>
+            <a:xfrm>
+              <a:off x="1236472" y="421665"/>
+              <a:ext cx="310959" cy="556234"/>
+            </a:xfrm>
+            <a:prstGeom prst="rect">
+              <a:avLst/>
+            </a:prstGeom>
+          </p:spPr>
+        </p:pic>
+        <p:sp>
+          <p:nvSpPr>
+            <p:cNvPr id="30" name="Graphic 30">
+              <a:extLst>
+                <a:ext uri="{FF2B5EF4-FFF2-40B4-BE49-F238E27FC236}">
+                  <a16:creationId xmlns:a16="http://schemas.microsoft.com/office/drawing/2014/main" id="{2318883D-5487-7FC9-913A-84902E795C7E}"/>
+                </a:ext>
+              </a:extLst>
+            </p:cNvPr>
+            <p:cNvSpPr/>
+            <p:nvPr/>
+          </p:nvSpPr>
+          <p:spPr>
+            <a:xfrm>
+              <a:off x="1336675" y="441324"/>
+              <a:ext cx="114300" cy="360045"/>
+            </a:xfrm>
+            <a:custGeom>
+              <a:avLst/>
+              <a:gdLst/>
+              <a:ahLst/>
+              <a:cxnLst/>
+              <a:rect l="l" t="t" r="r" b="b"/>
+              <a:pathLst>
+                <a:path w="114300" h="360045">
+                  <a:moveTo>
+                    <a:pt x="114300" y="245745"/>
+                  </a:moveTo>
+                  <a:lnTo>
+                    <a:pt x="76200" y="245745"/>
+                  </a:lnTo>
+                  <a:lnTo>
+                    <a:pt x="76200" y="0"/>
+                  </a:lnTo>
+                  <a:lnTo>
+                    <a:pt x="38100" y="0"/>
+                  </a:lnTo>
+                  <a:lnTo>
+                    <a:pt x="38100" y="245745"/>
+                  </a:lnTo>
+                  <a:lnTo>
+                    <a:pt x="0" y="245745"/>
+                  </a:lnTo>
+                  <a:lnTo>
+                    <a:pt x="57150" y="360045"/>
+                  </a:lnTo>
+                  <a:lnTo>
+                    <a:pt x="104775" y="264795"/>
+                  </a:lnTo>
+                  <a:lnTo>
+                    <a:pt x="114300" y="245745"/>
+                  </a:lnTo>
+                  <a:close/>
+                </a:path>
+              </a:pathLst>
+            </a:custGeom>
+            <a:solidFill>
+              <a:srgbClr val="4F81BB"/>
+            </a:solidFill>
+          </p:spPr>
+          <p:txBody>
+            <a:bodyPr wrap="square" lIns="0" tIns="0" rIns="0" bIns="0" rtlCol="0">
+              <a:prstTxWarp prst="textNoShape">
+                <a:avLst/>
+              </a:prstTxWarp>
+              <a:noAutofit/>
+            </a:bodyPr>
+            <a:lstStyle/>
+            <a:p>
+              <a:endParaRPr lang="en-IN" sz="1050"/>
+            </a:p>
+          </p:txBody>
+        </p:sp>
+        <p:pic>
+          <p:nvPicPr>
+            <p:cNvPr id="31" name="Image 31">
+              <a:extLst>
+                <a:ext uri="{FF2B5EF4-FFF2-40B4-BE49-F238E27FC236}">
+                  <a16:creationId xmlns:a16="http://schemas.microsoft.com/office/drawing/2014/main" id="{905636C8-FE1B-3027-E121-F163E98D4718}"/>
+                </a:ext>
+              </a:extLst>
+            </p:cNvPr>
+            <p:cNvPicPr/>
+            <p:nvPr/>
+          </p:nvPicPr>
+          <p:blipFill>
+            <a:blip r:embed="rId9" cstate="print"/>
+            <a:stretch>
+              <a:fillRect/>
+            </a:stretch>
+          </p:blipFill>
+          <p:spPr>
+            <a:xfrm>
+              <a:off x="1230375" y="1163853"/>
+              <a:ext cx="310959" cy="638530"/>
+            </a:xfrm>
+            <a:prstGeom prst="rect">
+              <a:avLst/>
+            </a:prstGeom>
+          </p:spPr>
+        </p:pic>
+        <p:pic>
+          <p:nvPicPr>
+            <p:cNvPr id="32" name="Image 32">
+              <a:extLst>
+                <a:ext uri="{FF2B5EF4-FFF2-40B4-BE49-F238E27FC236}">
+                  <a16:creationId xmlns:a16="http://schemas.microsoft.com/office/drawing/2014/main" id="{2DC07CEF-3495-9F63-C21F-1C34C50001E0}"/>
+                </a:ext>
+              </a:extLst>
+            </p:cNvPr>
+            <p:cNvPicPr/>
+            <p:nvPr/>
+          </p:nvPicPr>
+          <p:blipFill>
+            <a:blip r:embed="rId10" cstate="print"/>
+            <a:stretch>
+              <a:fillRect/>
+            </a:stretch>
+          </p:blipFill>
+          <p:spPr>
+            <a:xfrm>
+              <a:off x="1332611" y="1511046"/>
+              <a:ext cx="114300" cy="115188"/>
+            </a:xfrm>
+            <a:prstGeom prst="rect">
+              <a:avLst/>
+            </a:prstGeom>
+          </p:spPr>
+        </p:pic>
+        <p:sp>
+          <p:nvSpPr>
+            <p:cNvPr id="33" name="Graphic 33">
+              <a:extLst>
+                <a:ext uri="{FF2B5EF4-FFF2-40B4-BE49-F238E27FC236}">
+                  <a16:creationId xmlns:a16="http://schemas.microsoft.com/office/drawing/2014/main" id="{47840375-56BC-EEF5-5426-09C084F54591}"/>
+                </a:ext>
+              </a:extLst>
+            </p:cNvPr>
+            <p:cNvSpPr/>
+            <p:nvPr/>
+          </p:nvSpPr>
+          <p:spPr>
+            <a:xfrm>
+              <a:off x="1370711" y="1184021"/>
+              <a:ext cx="43180" cy="328295"/>
+            </a:xfrm>
+            <a:custGeom>
+              <a:avLst/>
+              <a:gdLst/>
+              <a:ahLst/>
+              <a:cxnLst/>
+              <a:rect l="l" t="t" r="r" b="b"/>
+              <a:pathLst>
+                <a:path w="43180" h="328295">
+                  <a:moveTo>
+                    <a:pt x="4699" y="0"/>
+                  </a:moveTo>
+                  <a:lnTo>
+                    <a:pt x="0" y="327660"/>
+                  </a:lnTo>
+                  <a:lnTo>
+                    <a:pt x="38100" y="328167"/>
+                  </a:lnTo>
+                  <a:lnTo>
+                    <a:pt x="42799" y="508"/>
+                  </a:lnTo>
+                  <a:lnTo>
+                    <a:pt x="4699" y="0"/>
+                  </a:lnTo>
+                  <a:close/>
+                </a:path>
+              </a:pathLst>
+            </a:custGeom>
+            <a:solidFill>
+              <a:srgbClr val="4F81BB"/>
+            </a:solidFill>
+          </p:spPr>
+          <p:txBody>
+            <a:bodyPr wrap="square" lIns="0" tIns="0" rIns="0" bIns="0" rtlCol="0">
+              <a:prstTxWarp prst="textNoShape">
+                <a:avLst/>
+              </a:prstTxWarp>
+              <a:noAutofit/>
+            </a:bodyPr>
+            <a:lstStyle/>
+            <a:p>
+              <a:endParaRPr lang="en-IN" sz="1050"/>
+            </a:p>
+          </p:txBody>
+        </p:sp>
+        <p:pic>
+          <p:nvPicPr>
+            <p:cNvPr id="34" name="Image 34">
+              <a:extLst>
+                <a:ext uri="{FF2B5EF4-FFF2-40B4-BE49-F238E27FC236}">
+                  <a16:creationId xmlns:a16="http://schemas.microsoft.com/office/drawing/2014/main" id="{F46E9C8E-16FD-22D3-041D-F6B13D1343AF}"/>
+                </a:ext>
+              </a:extLst>
+            </p:cNvPr>
+            <p:cNvPicPr/>
+            <p:nvPr/>
+          </p:nvPicPr>
+          <p:blipFill>
+            <a:blip r:embed="rId11" cstate="print"/>
+            <a:stretch>
+              <a:fillRect/>
+            </a:stretch>
+          </p:blipFill>
+          <p:spPr>
+            <a:xfrm>
+              <a:off x="1201419" y="2052320"/>
+              <a:ext cx="310959" cy="562356"/>
+            </a:xfrm>
+            <a:prstGeom prst="rect">
+              <a:avLst/>
+            </a:prstGeom>
+          </p:spPr>
+        </p:pic>
+        <p:sp>
+          <p:nvSpPr>
+            <p:cNvPr id="35" name="Graphic 35">
+              <a:extLst>
+                <a:ext uri="{FF2B5EF4-FFF2-40B4-BE49-F238E27FC236}">
+                  <a16:creationId xmlns:a16="http://schemas.microsoft.com/office/drawing/2014/main" id="{93505DFC-5A80-2ABA-9D68-003E15AF62A9}"/>
+                </a:ext>
+              </a:extLst>
+            </p:cNvPr>
+            <p:cNvSpPr/>
+            <p:nvPr/>
+          </p:nvSpPr>
+          <p:spPr>
+            <a:xfrm>
+              <a:off x="1302385" y="2072004"/>
+              <a:ext cx="114300" cy="367030"/>
+            </a:xfrm>
+            <a:custGeom>
+              <a:avLst/>
+              <a:gdLst/>
+              <a:ahLst/>
+              <a:cxnLst/>
+              <a:rect l="l" t="t" r="r" b="b"/>
+              <a:pathLst>
+                <a:path w="114300" h="367030">
+                  <a:moveTo>
+                    <a:pt x="114300" y="252730"/>
+                  </a:moveTo>
+                  <a:lnTo>
+                    <a:pt x="76200" y="252730"/>
+                  </a:lnTo>
+                  <a:lnTo>
+                    <a:pt x="76200" y="0"/>
+                  </a:lnTo>
+                  <a:lnTo>
+                    <a:pt x="38100" y="0"/>
+                  </a:lnTo>
+                  <a:lnTo>
+                    <a:pt x="38100" y="252730"/>
+                  </a:lnTo>
+                  <a:lnTo>
+                    <a:pt x="0" y="252730"/>
+                  </a:lnTo>
+                  <a:lnTo>
+                    <a:pt x="57150" y="367030"/>
+                  </a:lnTo>
+                  <a:lnTo>
+                    <a:pt x="104775" y="271780"/>
+                  </a:lnTo>
+                  <a:lnTo>
+                    <a:pt x="114300" y="252730"/>
+                  </a:lnTo>
+                  <a:close/>
+                </a:path>
+              </a:pathLst>
+            </a:custGeom>
+            <a:solidFill>
+              <a:srgbClr val="4F81BB"/>
+            </a:solidFill>
+          </p:spPr>
+          <p:txBody>
+            <a:bodyPr wrap="square" lIns="0" tIns="0" rIns="0" bIns="0" rtlCol="0">
+              <a:prstTxWarp prst="textNoShape">
+                <a:avLst/>
+              </a:prstTxWarp>
+              <a:noAutofit/>
+            </a:bodyPr>
+            <a:lstStyle/>
+            <a:p>
+              <a:endParaRPr lang="en-IN" sz="1050"/>
+            </a:p>
+          </p:txBody>
+        </p:sp>
+        <p:pic>
+          <p:nvPicPr>
+            <p:cNvPr id="36" name="Image 36">
+              <a:extLst>
+                <a:ext uri="{FF2B5EF4-FFF2-40B4-BE49-F238E27FC236}">
+                  <a16:creationId xmlns:a16="http://schemas.microsoft.com/office/drawing/2014/main" id="{EA2090DD-2EF2-4B58-B479-B9DB2C8D3F51}"/>
+                </a:ext>
+              </a:extLst>
+            </p:cNvPr>
+            <p:cNvPicPr/>
+            <p:nvPr/>
+          </p:nvPicPr>
+          <p:blipFill>
+            <a:blip r:embed="rId12" cstate="print"/>
+            <a:stretch>
+              <a:fillRect/>
+            </a:stretch>
+          </p:blipFill>
+          <p:spPr>
+            <a:xfrm>
+              <a:off x="1239519" y="2901188"/>
+              <a:ext cx="310959" cy="653796"/>
+            </a:xfrm>
+            <a:prstGeom prst="rect">
+              <a:avLst/>
+            </a:prstGeom>
+          </p:spPr>
+        </p:pic>
+        <p:pic>
+          <p:nvPicPr>
+            <p:cNvPr id="37" name="Image 37">
+              <a:extLst>
+                <a:ext uri="{FF2B5EF4-FFF2-40B4-BE49-F238E27FC236}">
+                  <a16:creationId xmlns:a16="http://schemas.microsoft.com/office/drawing/2014/main" id="{7F58DDC9-20B4-41F2-5A3B-FF03698E375A}"/>
+                </a:ext>
+              </a:extLst>
+            </p:cNvPr>
+            <p:cNvPicPr/>
+            <p:nvPr/>
+          </p:nvPicPr>
+          <p:blipFill>
+            <a:blip r:embed="rId13" cstate="print"/>
+            <a:stretch>
+              <a:fillRect/>
+            </a:stretch>
+          </p:blipFill>
+          <p:spPr>
+            <a:xfrm>
+              <a:off x="1338961" y="3263772"/>
+              <a:ext cx="114173" cy="115062"/>
+            </a:xfrm>
+            <a:prstGeom prst="rect">
+              <a:avLst/>
+            </a:prstGeom>
+          </p:spPr>
+        </p:pic>
+        <p:sp>
+          <p:nvSpPr>
+            <p:cNvPr id="38" name="Graphic 38">
+              <a:extLst>
+                <a:ext uri="{FF2B5EF4-FFF2-40B4-BE49-F238E27FC236}">
+                  <a16:creationId xmlns:a16="http://schemas.microsoft.com/office/drawing/2014/main" id="{B060CE53-48D9-2561-21C4-EC06142C1F7D}"/>
+                </a:ext>
+              </a:extLst>
+            </p:cNvPr>
+            <p:cNvSpPr/>
+            <p:nvPr/>
+          </p:nvSpPr>
+          <p:spPr>
+            <a:xfrm>
+              <a:off x="1372235" y="2921380"/>
+              <a:ext cx="43180" cy="343535"/>
+            </a:xfrm>
+            <a:custGeom>
+              <a:avLst/>
+              <a:gdLst/>
+              <a:ahLst/>
+              <a:cxnLst/>
+              <a:rect l="l" t="t" r="r" b="b"/>
+              <a:pathLst>
+                <a:path w="43180" h="343535">
+                  <a:moveTo>
+                    <a:pt x="38100" y="0"/>
+                  </a:moveTo>
+                  <a:lnTo>
+                    <a:pt x="0" y="507"/>
+                  </a:lnTo>
+                  <a:lnTo>
+                    <a:pt x="4825" y="343407"/>
+                  </a:lnTo>
+                  <a:lnTo>
+                    <a:pt x="42925" y="342900"/>
+                  </a:lnTo>
+                  <a:lnTo>
+                    <a:pt x="38100" y="0"/>
+                  </a:lnTo>
+                  <a:close/>
+                </a:path>
+              </a:pathLst>
+            </a:custGeom>
+            <a:solidFill>
+              <a:srgbClr val="4F81BB"/>
+            </a:solidFill>
+          </p:spPr>
+          <p:txBody>
+            <a:bodyPr wrap="square" lIns="0" tIns="0" rIns="0" bIns="0" rtlCol="0">
+              <a:prstTxWarp prst="textNoShape">
+                <a:avLst/>
+              </a:prstTxWarp>
+              <a:noAutofit/>
+            </a:bodyPr>
+            <a:lstStyle/>
+            <a:p>
+              <a:endParaRPr lang="en-IN" sz="1050"/>
+            </a:p>
+          </p:txBody>
+        </p:sp>
+        <p:sp>
+          <p:nvSpPr>
+            <p:cNvPr id="39" name="Graphic 39">
+              <a:extLst>
+                <a:ext uri="{FF2B5EF4-FFF2-40B4-BE49-F238E27FC236}">
+                  <a16:creationId xmlns:a16="http://schemas.microsoft.com/office/drawing/2014/main" id="{3BFBA69B-09E0-3B8F-48DE-17A9AF818C0C}"/>
+                </a:ext>
+              </a:extLst>
+            </p:cNvPr>
+            <p:cNvSpPr/>
+            <p:nvPr/>
+          </p:nvSpPr>
+          <p:spPr>
+            <a:xfrm>
+              <a:off x="12700" y="5859779"/>
+              <a:ext cx="3027045" cy="374015"/>
+            </a:xfrm>
+            <a:custGeom>
+              <a:avLst/>
+              <a:gdLst/>
+              <a:ahLst/>
+              <a:cxnLst/>
+              <a:rect l="l" t="t" r="r" b="b"/>
+              <a:pathLst>
+                <a:path w="3027045" h="374015">
+                  <a:moveTo>
+                    <a:pt x="0" y="374014"/>
+                  </a:moveTo>
+                  <a:lnTo>
+                    <a:pt x="3027045" y="374014"/>
+                  </a:lnTo>
+                  <a:lnTo>
+                    <a:pt x="3027045" y="0"/>
+                  </a:lnTo>
+                  <a:lnTo>
+                    <a:pt x="0" y="0"/>
+                  </a:lnTo>
+                  <a:lnTo>
+                    <a:pt x="0" y="374014"/>
+                  </a:lnTo>
+                  <a:close/>
+                </a:path>
+              </a:pathLst>
+            </a:custGeom>
+            <a:ln w="25400">
+              <a:solidFill>
+                <a:srgbClr val="4F81BB"/>
+              </a:solidFill>
+              <a:prstDash val="solid"/>
+            </a:ln>
+          </p:spPr>
+          <p:txBody>
+            <a:bodyPr wrap="square" lIns="0" tIns="0" rIns="0" bIns="0" rtlCol="0">
+              <a:prstTxWarp prst="textNoShape">
+                <a:avLst/>
+              </a:prstTxWarp>
+              <a:noAutofit/>
+            </a:bodyPr>
+            <a:lstStyle/>
+            <a:p>
+              <a:endParaRPr lang="en-IN" sz="1050"/>
+            </a:p>
+          </p:txBody>
+        </p:sp>
+        <p:pic>
+          <p:nvPicPr>
+            <p:cNvPr id="40" name="Image 40">
+              <a:extLst>
+                <a:ext uri="{FF2B5EF4-FFF2-40B4-BE49-F238E27FC236}">
+                  <a16:creationId xmlns:a16="http://schemas.microsoft.com/office/drawing/2014/main" id="{60322DF7-4795-90D2-B554-FC36801606D3}"/>
+                </a:ext>
+              </a:extLst>
+            </p:cNvPr>
+            <p:cNvPicPr/>
+            <p:nvPr/>
+          </p:nvPicPr>
+          <p:blipFill>
+            <a:blip r:embed="rId14" cstate="print"/>
+            <a:stretch>
+              <a:fillRect/>
+            </a:stretch>
+          </p:blipFill>
+          <p:spPr>
+            <a:xfrm>
+              <a:off x="1184655" y="5339575"/>
+              <a:ext cx="310959" cy="716292"/>
+            </a:xfrm>
+            <a:prstGeom prst="rect">
+              <a:avLst/>
+            </a:prstGeom>
+          </p:spPr>
+        </p:pic>
+        <p:sp>
+          <p:nvSpPr>
+            <p:cNvPr id="41" name="Graphic 41">
+              <a:extLst>
+                <a:ext uri="{FF2B5EF4-FFF2-40B4-BE49-F238E27FC236}">
+                  <a16:creationId xmlns:a16="http://schemas.microsoft.com/office/drawing/2014/main" id="{CB0B1B57-0102-B994-E61F-FECDB6BCE069}"/>
+                </a:ext>
+              </a:extLst>
+            </p:cNvPr>
+            <p:cNvSpPr/>
+            <p:nvPr/>
+          </p:nvSpPr>
+          <p:spPr>
+            <a:xfrm>
+              <a:off x="1285240" y="5360034"/>
+              <a:ext cx="114300" cy="519430"/>
+            </a:xfrm>
+            <a:custGeom>
+              <a:avLst/>
+              <a:gdLst/>
+              <a:ahLst/>
+              <a:cxnLst/>
+              <a:rect l="l" t="t" r="r" b="b"/>
+              <a:pathLst>
+                <a:path w="114300" h="519430">
+                  <a:moveTo>
+                    <a:pt x="114300" y="405130"/>
+                  </a:moveTo>
+                  <a:lnTo>
+                    <a:pt x="76200" y="405130"/>
+                  </a:lnTo>
+                  <a:lnTo>
+                    <a:pt x="76200" y="0"/>
+                  </a:lnTo>
+                  <a:lnTo>
+                    <a:pt x="38100" y="0"/>
+                  </a:lnTo>
+                  <a:lnTo>
+                    <a:pt x="38100" y="405130"/>
+                  </a:lnTo>
+                  <a:lnTo>
+                    <a:pt x="0" y="405130"/>
+                  </a:lnTo>
+                  <a:lnTo>
+                    <a:pt x="57150" y="519430"/>
+                  </a:lnTo>
+                  <a:lnTo>
+                    <a:pt x="104775" y="424180"/>
+                  </a:lnTo>
+                  <a:lnTo>
+                    <a:pt x="114300" y="405130"/>
+                  </a:lnTo>
+                  <a:close/>
+                </a:path>
+              </a:pathLst>
+            </a:custGeom>
+            <a:solidFill>
+              <a:srgbClr val="4F81BB"/>
+            </a:solidFill>
+          </p:spPr>
+          <p:txBody>
+            <a:bodyPr wrap="square" lIns="0" tIns="0" rIns="0" bIns="0" rtlCol="0">
+              <a:prstTxWarp prst="textNoShape">
+                <a:avLst/>
+              </a:prstTxWarp>
+              <a:noAutofit/>
+            </a:bodyPr>
+            <a:lstStyle/>
+            <a:p>
+              <a:endParaRPr lang="en-IN" sz="1050"/>
+            </a:p>
+          </p:txBody>
+        </p:sp>
+        <p:sp>
+          <p:nvSpPr>
+            <p:cNvPr id="42" name="Textbox 42">
+              <a:extLst>
+                <a:ext uri="{FF2B5EF4-FFF2-40B4-BE49-F238E27FC236}">
+                  <a16:creationId xmlns:a16="http://schemas.microsoft.com/office/drawing/2014/main" id="{A1AF36D9-644B-FFE4-A217-B4B804964439}"/>
+                </a:ext>
+              </a:extLst>
+            </p:cNvPr>
+            <p:cNvSpPr txBox="1"/>
+            <p:nvPr/>
+          </p:nvSpPr>
+          <p:spPr>
+            <a:xfrm>
+              <a:off x="15450" y="66734"/>
+              <a:ext cx="2895600" cy="394335"/>
+            </a:xfrm>
+            <a:prstGeom prst="rect">
+              <a:avLst/>
+            </a:prstGeom>
+            <a:ln w="25400">
+              <a:solidFill>
+                <a:srgbClr val="4F81BB"/>
+              </a:solidFill>
+              <a:prstDash val="solid"/>
+            </a:ln>
+          </p:spPr>
+          <p:txBody>
+            <a:bodyPr wrap="square" lIns="0" tIns="0" rIns="0" bIns="0" rtlCol="0">
+              <a:noAutofit/>
+            </a:bodyPr>
+            <a:lstStyle/>
+            <a:p>
+              <a:pPr marL="702945">
+                <a:spcBef>
+                  <a:spcPts val="405"/>
+                </a:spcBef>
+                <a:buNone/>
+              </a:pPr>
+              <a:r>
+                <a:rPr lang="en-US" sz="1050" dirty="0">
+                  <a:effectLst/>
+                  <a:latin typeface="Microsoft Sans Serif" panose="020B0604020202020204" pitchFamily="34" charset="0"/>
+                  <a:ea typeface="Microsoft Sans Serif" panose="020B0604020202020204" pitchFamily="34" charset="0"/>
+                </a:rPr>
+                <a:t>Problem</a:t>
+              </a:r>
+              <a:r>
+                <a:rPr lang="en-US" sz="1050" spc="-30" dirty="0">
+                  <a:effectLst/>
+                  <a:latin typeface="Microsoft Sans Serif" panose="020B0604020202020204" pitchFamily="34" charset="0"/>
+                  <a:ea typeface="Microsoft Sans Serif" panose="020B0604020202020204" pitchFamily="34" charset="0"/>
+                </a:rPr>
+                <a:t> </a:t>
+              </a:r>
+              <a:r>
+                <a:rPr lang="en-US" sz="1050" spc="-10" dirty="0">
+                  <a:effectLst/>
+                  <a:latin typeface="Microsoft Sans Serif" panose="020B0604020202020204" pitchFamily="34" charset="0"/>
+                  <a:ea typeface="Microsoft Sans Serif" panose="020B0604020202020204" pitchFamily="34" charset="0"/>
+                </a:rPr>
+                <a:t>Understanding</a:t>
+              </a:r>
+              <a:endParaRPr lang="en-IN" sz="1050" dirty="0">
+                <a:effectLst/>
+                <a:latin typeface="Microsoft Sans Serif" panose="020B0604020202020204" pitchFamily="34" charset="0"/>
+                <a:ea typeface="Microsoft Sans Serif" panose="020B0604020202020204" pitchFamily="34" charset="0"/>
+              </a:endParaRPr>
+            </a:p>
+          </p:txBody>
+        </p:sp>
+        <p:sp>
+          <p:nvSpPr>
+            <p:cNvPr id="43" name="Textbox 43">
+              <a:extLst>
+                <a:ext uri="{FF2B5EF4-FFF2-40B4-BE49-F238E27FC236}">
+                  <a16:creationId xmlns:a16="http://schemas.microsoft.com/office/drawing/2014/main" id="{242189AD-DD6E-7248-B1C4-C85EE6E8B233}"/>
+                </a:ext>
+              </a:extLst>
+            </p:cNvPr>
+            <p:cNvSpPr txBox="1"/>
+            <p:nvPr/>
+          </p:nvSpPr>
+          <p:spPr>
+            <a:xfrm>
+              <a:off x="1007617" y="2533681"/>
+              <a:ext cx="1381879" cy="267938"/>
+            </a:xfrm>
+            <a:prstGeom prst="rect">
+              <a:avLst/>
+            </a:prstGeom>
+          </p:spPr>
+          <p:txBody>
+            <a:bodyPr wrap="square" lIns="0" tIns="0" rIns="0" bIns="0" rtlCol="0">
+              <a:noAutofit/>
+            </a:bodyPr>
+            <a:lstStyle/>
+            <a:p>
+              <a:pPr>
+                <a:buNone/>
+              </a:pPr>
+              <a:r>
+                <a:rPr lang="en-US" sz="1050" dirty="0">
+                  <a:effectLst/>
+                  <a:latin typeface="Microsoft Sans Serif" panose="020B0604020202020204" pitchFamily="34" charset="0"/>
+                  <a:ea typeface="Microsoft Sans Serif" panose="020B0604020202020204" pitchFamily="34" charset="0"/>
+                </a:rPr>
+                <a:t>Data </a:t>
+              </a:r>
+              <a:r>
+                <a:rPr lang="en-US" sz="1050" spc="-10" dirty="0">
+                  <a:effectLst/>
+                  <a:latin typeface="Microsoft Sans Serif" panose="020B0604020202020204" pitchFamily="34" charset="0"/>
+                  <a:ea typeface="Microsoft Sans Serif" panose="020B0604020202020204" pitchFamily="34" charset="0"/>
+                </a:rPr>
+                <a:t>Connection</a:t>
+              </a:r>
+              <a:endParaRPr lang="en-IN" sz="1050" dirty="0">
+                <a:effectLst/>
+                <a:latin typeface="Microsoft Sans Serif" panose="020B0604020202020204" pitchFamily="34" charset="0"/>
+                <a:ea typeface="Microsoft Sans Serif" panose="020B0604020202020204" pitchFamily="34" charset="0"/>
+              </a:endParaRPr>
+            </a:p>
+          </p:txBody>
+        </p:sp>
+        <p:sp>
+          <p:nvSpPr>
+            <p:cNvPr id="44" name="Textbox 44">
+              <a:extLst>
+                <a:ext uri="{FF2B5EF4-FFF2-40B4-BE49-F238E27FC236}">
+                  <a16:creationId xmlns:a16="http://schemas.microsoft.com/office/drawing/2014/main" id="{07C5C51E-44AD-1927-9679-10CD846DE3E2}"/>
+                </a:ext>
+              </a:extLst>
+            </p:cNvPr>
+            <p:cNvSpPr txBox="1"/>
+            <p:nvPr/>
+          </p:nvSpPr>
+          <p:spPr>
+            <a:xfrm>
+              <a:off x="882650" y="3414805"/>
+              <a:ext cx="1758015" cy="317625"/>
+            </a:xfrm>
+            <a:prstGeom prst="rect">
+              <a:avLst/>
+            </a:prstGeom>
+          </p:spPr>
+          <p:txBody>
+            <a:bodyPr wrap="square" lIns="0" tIns="0" rIns="0" bIns="0" rtlCol="0">
+              <a:noAutofit/>
+            </a:bodyPr>
+            <a:lstStyle/>
+            <a:p>
+              <a:pPr>
+                <a:buNone/>
+              </a:pPr>
+              <a:r>
+                <a:rPr lang="en-US" sz="1050" dirty="0">
+                  <a:effectLst/>
+                  <a:latin typeface="Microsoft Sans Serif" panose="020B0604020202020204" pitchFamily="34" charset="0"/>
+                  <a:ea typeface="Microsoft Sans Serif" panose="020B0604020202020204" pitchFamily="34" charset="0"/>
+                </a:rPr>
+                <a:t>Data</a:t>
+              </a:r>
+              <a:r>
+                <a:rPr lang="en-US" sz="1050" spc="-25" dirty="0">
+                  <a:effectLst/>
+                  <a:latin typeface="Microsoft Sans Serif" panose="020B0604020202020204" pitchFamily="34" charset="0"/>
+                  <a:ea typeface="Microsoft Sans Serif" panose="020B0604020202020204" pitchFamily="34" charset="0"/>
+                </a:rPr>
+                <a:t> </a:t>
+              </a:r>
+              <a:r>
+                <a:rPr lang="en-US" sz="1050" spc="-10" dirty="0" err="1">
+                  <a:effectLst/>
+                  <a:latin typeface="Microsoft Sans Serif" panose="020B0604020202020204" pitchFamily="34" charset="0"/>
+                  <a:ea typeface="Microsoft Sans Serif" panose="020B0604020202020204" pitchFamily="34" charset="0"/>
+                </a:rPr>
+                <a:t>Preproccessing</a:t>
+              </a:r>
+              <a:endParaRPr lang="en-IN" sz="1050" dirty="0">
+                <a:effectLst/>
+                <a:latin typeface="Microsoft Sans Serif" panose="020B0604020202020204" pitchFamily="34" charset="0"/>
+                <a:ea typeface="Microsoft Sans Serif" panose="020B0604020202020204" pitchFamily="34" charset="0"/>
+              </a:endParaRPr>
+            </a:p>
+          </p:txBody>
+        </p:sp>
+        <p:sp>
+          <p:nvSpPr>
+            <p:cNvPr id="45" name="Textbox 45">
+              <a:extLst>
+                <a:ext uri="{FF2B5EF4-FFF2-40B4-BE49-F238E27FC236}">
+                  <a16:creationId xmlns:a16="http://schemas.microsoft.com/office/drawing/2014/main" id="{BB6B97D8-4BA2-3BF0-33D5-72B3E8D3E081}"/>
+                </a:ext>
+              </a:extLst>
+            </p:cNvPr>
+            <p:cNvSpPr txBox="1"/>
+            <p:nvPr/>
+          </p:nvSpPr>
+          <p:spPr>
+            <a:xfrm>
+              <a:off x="73660" y="1653539"/>
+              <a:ext cx="2854325" cy="410845"/>
+            </a:xfrm>
+            <a:prstGeom prst="rect">
+              <a:avLst/>
+            </a:prstGeom>
+          </p:spPr>
+          <p:txBody>
+            <a:bodyPr wrap="square" lIns="0" tIns="0" rIns="0" bIns="0" rtlCol="0">
+              <a:noAutofit/>
+            </a:bodyPr>
+            <a:lstStyle/>
+            <a:p>
+              <a:pPr marL="808355">
+                <a:spcBef>
+                  <a:spcPts val="380"/>
+                </a:spcBef>
+                <a:buNone/>
+              </a:pPr>
+              <a:r>
+                <a:rPr lang="en-US" sz="1050" dirty="0">
+                  <a:effectLst/>
+                  <a:latin typeface="Microsoft Sans Serif" panose="020B0604020202020204" pitchFamily="34" charset="0"/>
+                  <a:ea typeface="Microsoft Sans Serif" panose="020B0604020202020204" pitchFamily="34" charset="0"/>
+                </a:rPr>
+                <a:t>Data </a:t>
+              </a:r>
+              <a:r>
+                <a:rPr lang="en-US" sz="1050" spc="-10" dirty="0">
+                  <a:effectLst/>
+                  <a:latin typeface="Microsoft Sans Serif" panose="020B0604020202020204" pitchFamily="34" charset="0"/>
+                  <a:ea typeface="Microsoft Sans Serif" panose="020B0604020202020204" pitchFamily="34" charset="0"/>
+                </a:rPr>
+                <a:t>Understanding</a:t>
+              </a:r>
+              <a:endParaRPr lang="en-IN" sz="1050" dirty="0">
+                <a:effectLst/>
+                <a:latin typeface="Microsoft Sans Serif" panose="020B0604020202020204" pitchFamily="34" charset="0"/>
+                <a:ea typeface="Microsoft Sans Serif" panose="020B0604020202020204" pitchFamily="34" charset="0"/>
+              </a:endParaRPr>
+            </a:p>
+          </p:txBody>
+        </p:sp>
+        <p:sp>
+          <p:nvSpPr>
+            <p:cNvPr id="46" name="Textbox 46">
+              <a:extLst>
+                <a:ext uri="{FF2B5EF4-FFF2-40B4-BE49-F238E27FC236}">
+                  <a16:creationId xmlns:a16="http://schemas.microsoft.com/office/drawing/2014/main" id="{F3D053F6-E6AB-7B77-B5A5-02BBC6B817C1}"/>
+                </a:ext>
+              </a:extLst>
+            </p:cNvPr>
+            <p:cNvSpPr txBox="1"/>
+            <p:nvPr/>
+          </p:nvSpPr>
+          <p:spPr>
+            <a:xfrm>
+              <a:off x="25400" y="5872479"/>
+              <a:ext cx="3001645" cy="348615"/>
+            </a:xfrm>
+            <a:prstGeom prst="rect">
+              <a:avLst/>
+            </a:prstGeom>
+          </p:spPr>
+          <p:txBody>
+            <a:bodyPr wrap="square" lIns="0" tIns="0" rIns="0" bIns="0" rtlCol="0">
+              <a:noAutofit/>
+            </a:bodyPr>
+            <a:lstStyle/>
+            <a:p>
+              <a:pPr marL="942340">
+                <a:spcBef>
+                  <a:spcPts val="360"/>
+                </a:spcBef>
+                <a:buNone/>
+              </a:pPr>
+              <a:r>
+                <a:rPr lang="en-US" sz="1050">
+                  <a:effectLst/>
+                  <a:latin typeface="Microsoft Sans Serif" panose="020B0604020202020204" pitchFamily="34" charset="0"/>
+                  <a:ea typeface="Microsoft Sans Serif" panose="020B0604020202020204" pitchFamily="34" charset="0"/>
+                </a:rPr>
+                <a:t>Data</a:t>
+              </a:r>
+              <a:r>
+                <a:rPr lang="en-US" sz="1050" spc="-25">
+                  <a:effectLst/>
+                  <a:latin typeface="Microsoft Sans Serif" panose="020B0604020202020204" pitchFamily="34" charset="0"/>
+                  <a:ea typeface="Microsoft Sans Serif" panose="020B0604020202020204" pitchFamily="34" charset="0"/>
+                </a:rPr>
+                <a:t> </a:t>
+              </a:r>
+              <a:r>
+                <a:rPr lang="en-US" sz="1050" spc="-10">
+                  <a:effectLst/>
+                  <a:latin typeface="Microsoft Sans Serif" panose="020B0604020202020204" pitchFamily="34" charset="0"/>
+                  <a:ea typeface="Microsoft Sans Serif" panose="020B0604020202020204" pitchFamily="34" charset="0"/>
+                </a:rPr>
+                <a:t>Visualisation</a:t>
+              </a:r>
+              <a:endParaRPr lang="en-IN" sz="1050">
+                <a:effectLst/>
+                <a:latin typeface="Microsoft Sans Serif" panose="020B0604020202020204" pitchFamily="34" charset="0"/>
+                <a:ea typeface="Microsoft Sans Serif" panose="020B0604020202020204" pitchFamily="34" charset="0"/>
+              </a:endParaRPr>
+            </a:p>
+          </p:txBody>
+        </p:sp>
+        <p:sp>
+          <p:nvSpPr>
+            <p:cNvPr id="47" name="Textbox 47">
+              <a:extLst>
+                <a:ext uri="{FF2B5EF4-FFF2-40B4-BE49-F238E27FC236}">
+                  <a16:creationId xmlns:a16="http://schemas.microsoft.com/office/drawing/2014/main" id="{53C2E696-9A09-1149-40FD-0F9BA4EF90DE}"/>
+                </a:ext>
+              </a:extLst>
+            </p:cNvPr>
+            <p:cNvSpPr txBox="1"/>
+            <p:nvPr/>
+          </p:nvSpPr>
+          <p:spPr>
+            <a:xfrm>
+              <a:off x="745615" y="920114"/>
+              <a:ext cx="1643880" cy="275589"/>
+            </a:xfrm>
+            <a:prstGeom prst="rect">
+              <a:avLst/>
+            </a:prstGeom>
+          </p:spPr>
+          <p:txBody>
+            <a:bodyPr wrap="square" lIns="0" tIns="0" rIns="0" bIns="0" rtlCol="0">
+              <a:noAutofit/>
+            </a:bodyPr>
+            <a:lstStyle/>
+            <a:p>
+              <a:pPr>
+                <a:buNone/>
+              </a:pPr>
+              <a:r>
+                <a:rPr lang="en-US" sz="1050" dirty="0">
+                  <a:effectLst/>
+                  <a:latin typeface="Microsoft Sans Serif" panose="020B0604020202020204" pitchFamily="34" charset="0"/>
+                  <a:ea typeface="Microsoft Sans Serif" panose="020B0604020202020204" pitchFamily="34" charset="0"/>
+                </a:rPr>
+                <a:t>Data</a:t>
+              </a:r>
+              <a:r>
+                <a:rPr lang="en-US" sz="1050" spc="285" dirty="0">
+                  <a:effectLst/>
+                  <a:latin typeface="Microsoft Sans Serif" panose="020B0604020202020204" pitchFamily="34" charset="0"/>
+                  <a:ea typeface="Microsoft Sans Serif" panose="020B0604020202020204" pitchFamily="34" charset="0"/>
+                </a:rPr>
+                <a:t> </a:t>
+              </a:r>
+              <a:r>
+                <a:rPr lang="en-US" sz="1050" spc="-10" dirty="0">
+                  <a:effectLst/>
+                  <a:latin typeface="Microsoft Sans Serif" panose="020B0604020202020204" pitchFamily="34" charset="0"/>
+                  <a:ea typeface="Microsoft Sans Serif" panose="020B0604020202020204" pitchFamily="34" charset="0"/>
+                </a:rPr>
+                <a:t>Collection</a:t>
+              </a:r>
+              <a:endParaRPr lang="en-IN" sz="1050" dirty="0">
+                <a:effectLst/>
+                <a:latin typeface="Microsoft Sans Serif" panose="020B0604020202020204" pitchFamily="34" charset="0"/>
+                <a:ea typeface="Microsoft Sans Serif" panose="020B0604020202020204" pitchFamily="34" charset="0"/>
+              </a:endParaRPr>
+            </a:p>
+          </p:txBody>
+        </p:sp>
+        <p:sp>
+          <p:nvSpPr>
+            <p:cNvPr id="48" name="Textbox 48">
+              <a:extLst>
+                <a:ext uri="{FF2B5EF4-FFF2-40B4-BE49-F238E27FC236}">
+                  <a16:creationId xmlns:a16="http://schemas.microsoft.com/office/drawing/2014/main" id="{E1625203-A3C9-872A-0B53-D1604338DA66}"/>
+                </a:ext>
+              </a:extLst>
+            </p:cNvPr>
+            <p:cNvSpPr txBox="1"/>
+            <p:nvPr/>
+          </p:nvSpPr>
+          <p:spPr>
+            <a:xfrm>
+              <a:off x="0" y="5339575"/>
+              <a:ext cx="3121025" cy="1793875"/>
+            </a:xfrm>
+            <a:prstGeom prst="rect">
+              <a:avLst/>
+            </a:prstGeom>
+          </p:spPr>
+          <p:txBody>
+            <a:bodyPr wrap="square" lIns="0" tIns="0" rIns="0" bIns="0" rtlCol="0">
+              <a:noAutofit/>
+            </a:bodyPr>
+            <a:lstStyle/>
+            <a:p>
+              <a:pPr>
+                <a:buNone/>
+              </a:pPr>
+              <a:r>
+                <a:rPr lang="en-US" sz="1050" dirty="0">
+                  <a:effectLst/>
+                  <a:latin typeface="Calibri" panose="020F0502020204030204" pitchFamily="34" charset="0"/>
+                  <a:ea typeface="Microsoft Sans Serif" panose="020B0604020202020204" pitchFamily="34" charset="0"/>
+                  <a:cs typeface="Microsoft Sans Serif" panose="020B0604020202020204" pitchFamily="34" charset="0"/>
+                </a:rPr>
+                <a:t> </a:t>
+              </a:r>
+              <a:endParaRPr lang="en-IN" sz="1050" dirty="0">
+                <a:effectLst/>
+                <a:latin typeface="Microsoft Sans Serif" panose="020B0604020202020204" pitchFamily="34" charset="0"/>
+                <a:ea typeface="Microsoft Sans Serif" panose="020B0604020202020204" pitchFamily="34" charset="0"/>
+              </a:endParaRPr>
+            </a:p>
+            <a:p>
+              <a:pPr>
+                <a:buNone/>
+              </a:pPr>
+              <a:r>
+                <a:rPr lang="en-US" sz="1050" dirty="0">
+                  <a:effectLst/>
+                  <a:latin typeface="Calibri" panose="020F0502020204030204" pitchFamily="34" charset="0"/>
+                  <a:ea typeface="Microsoft Sans Serif" panose="020B0604020202020204" pitchFamily="34" charset="0"/>
+                  <a:cs typeface="Microsoft Sans Serif" panose="020B0604020202020204" pitchFamily="34" charset="0"/>
+                </a:rPr>
+                <a:t> </a:t>
+              </a:r>
+              <a:endParaRPr lang="en-IN" sz="1050" dirty="0">
+                <a:effectLst/>
+                <a:latin typeface="Microsoft Sans Serif" panose="020B0604020202020204" pitchFamily="34" charset="0"/>
+                <a:ea typeface="Microsoft Sans Serif" panose="020B0604020202020204" pitchFamily="34" charset="0"/>
+              </a:endParaRPr>
+            </a:p>
+            <a:p>
+              <a:pPr>
+                <a:buNone/>
+              </a:pPr>
+              <a:r>
+                <a:rPr lang="en-US" sz="1050" dirty="0">
+                  <a:effectLst/>
+                  <a:latin typeface="Calibri" panose="020F0502020204030204" pitchFamily="34" charset="0"/>
+                  <a:ea typeface="Microsoft Sans Serif" panose="020B0604020202020204" pitchFamily="34" charset="0"/>
+                  <a:cs typeface="Microsoft Sans Serif" panose="020B0604020202020204" pitchFamily="34" charset="0"/>
+                </a:rPr>
+                <a:t> </a:t>
+              </a:r>
+              <a:endParaRPr lang="en-IN" sz="1050" dirty="0">
+                <a:effectLst/>
+                <a:latin typeface="Microsoft Sans Serif" panose="020B0604020202020204" pitchFamily="34" charset="0"/>
+                <a:ea typeface="Microsoft Sans Serif" panose="020B0604020202020204" pitchFamily="34" charset="0"/>
+              </a:endParaRPr>
+            </a:p>
+            <a:p>
+              <a:pPr>
+                <a:buNone/>
+              </a:pPr>
+              <a:r>
+                <a:rPr lang="en-US" sz="1050" dirty="0">
+                  <a:effectLst/>
+                  <a:latin typeface="Calibri" panose="020F0502020204030204" pitchFamily="34" charset="0"/>
+                  <a:ea typeface="Microsoft Sans Serif" panose="020B0604020202020204" pitchFamily="34" charset="0"/>
+                  <a:cs typeface="Microsoft Sans Serif" panose="020B0604020202020204" pitchFamily="34" charset="0"/>
+                </a:rPr>
+                <a:t> </a:t>
+              </a:r>
+              <a:endParaRPr lang="en-IN" sz="1050" dirty="0">
+                <a:effectLst/>
+                <a:latin typeface="Microsoft Sans Serif" panose="020B0604020202020204" pitchFamily="34" charset="0"/>
+                <a:ea typeface="Microsoft Sans Serif" panose="020B0604020202020204" pitchFamily="34" charset="0"/>
+              </a:endParaRPr>
+            </a:p>
+            <a:p>
+              <a:pPr>
+                <a:buNone/>
+              </a:pPr>
+              <a:r>
+                <a:rPr lang="en-US" sz="1050" dirty="0">
+                  <a:effectLst/>
+                  <a:latin typeface="Calibri" panose="020F0502020204030204" pitchFamily="34" charset="0"/>
+                  <a:ea typeface="Microsoft Sans Serif" panose="020B0604020202020204" pitchFamily="34" charset="0"/>
+                  <a:cs typeface="Microsoft Sans Serif" panose="020B0604020202020204" pitchFamily="34" charset="0"/>
+                </a:rPr>
+                <a:t> </a:t>
+              </a:r>
+              <a:endParaRPr lang="en-IN" sz="1050" dirty="0">
+                <a:effectLst/>
+                <a:latin typeface="Microsoft Sans Serif" panose="020B0604020202020204" pitchFamily="34" charset="0"/>
+                <a:ea typeface="Microsoft Sans Serif" panose="020B0604020202020204" pitchFamily="34" charset="0"/>
+              </a:endParaRPr>
+            </a:p>
+            <a:p>
+              <a:pPr>
+                <a:buNone/>
+              </a:pPr>
+              <a:r>
+                <a:rPr lang="en-US" sz="1050" dirty="0">
+                  <a:effectLst/>
+                  <a:latin typeface="Calibri" panose="020F0502020204030204" pitchFamily="34" charset="0"/>
+                  <a:ea typeface="Microsoft Sans Serif" panose="020B0604020202020204" pitchFamily="34" charset="0"/>
+                  <a:cs typeface="Microsoft Sans Serif" panose="020B0604020202020204" pitchFamily="34" charset="0"/>
+                </a:rPr>
+                <a:t> </a:t>
+              </a:r>
+              <a:endParaRPr lang="en-IN" sz="1050" dirty="0">
+                <a:effectLst/>
+                <a:latin typeface="Microsoft Sans Serif" panose="020B0604020202020204" pitchFamily="34" charset="0"/>
+                <a:ea typeface="Microsoft Sans Serif" panose="020B0604020202020204" pitchFamily="34" charset="0"/>
+              </a:endParaRPr>
+            </a:p>
+            <a:p>
+              <a:pPr>
+                <a:buNone/>
+              </a:pPr>
+              <a:r>
+                <a:rPr lang="en-US" sz="1050" dirty="0">
+                  <a:effectLst/>
+                  <a:latin typeface="Calibri" panose="020F0502020204030204" pitchFamily="34" charset="0"/>
+                  <a:ea typeface="Microsoft Sans Serif" panose="020B0604020202020204" pitchFamily="34" charset="0"/>
+                  <a:cs typeface="Microsoft Sans Serif" panose="020B0604020202020204" pitchFamily="34" charset="0"/>
+                </a:rPr>
+                <a:t> </a:t>
+              </a:r>
+              <a:endParaRPr lang="en-IN" sz="1050" dirty="0">
+                <a:effectLst/>
+                <a:latin typeface="Microsoft Sans Serif" panose="020B0604020202020204" pitchFamily="34" charset="0"/>
+                <a:ea typeface="Microsoft Sans Serif" panose="020B0604020202020204" pitchFamily="34" charset="0"/>
+              </a:endParaRPr>
+            </a:p>
+            <a:p>
+              <a:pPr>
+                <a:spcBef>
+                  <a:spcPts val="895"/>
+                </a:spcBef>
+                <a:buNone/>
+              </a:pPr>
+              <a:r>
+                <a:rPr lang="en-US" sz="1050" dirty="0">
+                  <a:effectLst/>
+                  <a:latin typeface="Calibri" panose="020F0502020204030204" pitchFamily="34" charset="0"/>
+                  <a:ea typeface="Microsoft Sans Serif" panose="020B0604020202020204" pitchFamily="34" charset="0"/>
+                  <a:cs typeface="Microsoft Sans Serif" panose="020B0604020202020204" pitchFamily="34" charset="0"/>
+                </a:rPr>
+                <a:t> </a:t>
+              </a:r>
+              <a:endParaRPr lang="en-IN" sz="1050" dirty="0">
+                <a:effectLst/>
+                <a:latin typeface="Microsoft Sans Serif" panose="020B0604020202020204" pitchFamily="34" charset="0"/>
+                <a:ea typeface="Microsoft Sans Serif" panose="020B0604020202020204" pitchFamily="34" charset="0"/>
+              </a:endParaRPr>
+            </a:p>
+            <a:p>
+              <a:pPr marL="580390">
+                <a:buNone/>
+              </a:pPr>
+              <a:r>
+                <a:rPr lang="en-US" sz="1050" dirty="0">
+                  <a:effectLst/>
+                  <a:latin typeface="Microsoft Sans Serif" panose="020B0604020202020204" pitchFamily="34" charset="0"/>
+                  <a:ea typeface="Microsoft Sans Serif" panose="020B0604020202020204" pitchFamily="34" charset="0"/>
+                </a:rPr>
+                <a:t> </a:t>
+              </a:r>
+              <a:endParaRPr lang="en-IN" sz="1050" dirty="0">
+                <a:effectLst/>
+                <a:latin typeface="Microsoft Sans Serif" panose="020B0604020202020204" pitchFamily="34" charset="0"/>
+                <a:ea typeface="Microsoft Sans Serif" panose="020B0604020202020204" pitchFamily="34" charset="0"/>
+              </a:endParaRPr>
+            </a:p>
+          </p:txBody>
+        </p:sp>
+        <p:sp>
+          <p:nvSpPr>
+            <p:cNvPr id="49" name="Textbox 49">
+              <a:extLst>
+                <a:ext uri="{FF2B5EF4-FFF2-40B4-BE49-F238E27FC236}">
+                  <a16:creationId xmlns:a16="http://schemas.microsoft.com/office/drawing/2014/main" id="{0E6DABF1-5E44-B37B-8690-6455DECC0E77}"/>
+                </a:ext>
+              </a:extLst>
+            </p:cNvPr>
+            <p:cNvSpPr txBox="1"/>
+            <p:nvPr/>
+          </p:nvSpPr>
+          <p:spPr>
+            <a:xfrm>
+              <a:off x="74294" y="4224654"/>
+              <a:ext cx="2978150" cy="422275"/>
+            </a:xfrm>
+            <a:prstGeom prst="rect">
+              <a:avLst/>
+            </a:prstGeom>
+            <a:ln w="25400">
+              <a:solidFill>
+                <a:srgbClr val="4F81BB"/>
+              </a:solidFill>
+              <a:prstDash val="solid"/>
+            </a:ln>
+          </p:spPr>
+          <p:txBody>
+            <a:bodyPr wrap="square" lIns="0" tIns="0" rIns="0" bIns="0" rtlCol="0">
+              <a:noAutofit/>
+            </a:bodyPr>
+            <a:lstStyle/>
+            <a:p>
+              <a:pPr marL="3175" algn="ctr">
+                <a:spcBef>
+                  <a:spcPts val="415"/>
+                </a:spcBef>
+                <a:buNone/>
+              </a:pPr>
+              <a:r>
+                <a:rPr lang="en-US" sz="1050">
+                  <a:effectLst/>
+                  <a:latin typeface="Microsoft Sans Serif" panose="020B0604020202020204" pitchFamily="34" charset="0"/>
+                  <a:ea typeface="Microsoft Sans Serif" panose="020B0604020202020204" pitchFamily="34" charset="0"/>
+                </a:rPr>
+                <a:t>Data</a:t>
+              </a:r>
+              <a:r>
+                <a:rPr lang="en-US" sz="1050" spc="-25">
+                  <a:effectLst/>
+                  <a:latin typeface="Microsoft Sans Serif" panose="020B0604020202020204" pitchFamily="34" charset="0"/>
+                  <a:ea typeface="Microsoft Sans Serif" panose="020B0604020202020204" pitchFamily="34" charset="0"/>
+                </a:rPr>
+                <a:t> </a:t>
+              </a:r>
+              <a:r>
+                <a:rPr lang="en-US" sz="1050" spc="-10">
+                  <a:effectLst/>
+                  <a:latin typeface="Microsoft Sans Serif" panose="020B0604020202020204" pitchFamily="34" charset="0"/>
+                  <a:ea typeface="Microsoft Sans Serif" panose="020B0604020202020204" pitchFamily="34" charset="0"/>
+                </a:rPr>
+                <a:t>Analytics</a:t>
+              </a:r>
+              <a:endParaRPr lang="en-IN" sz="1050">
+                <a:effectLst/>
+                <a:latin typeface="Microsoft Sans Serif" panose="020B0604020202020204" pitchFamily="34" charset="0"/>
+                <a:ea typeface="Microsoft Sans Serif" panose="020B0604020202020204" pitchFamily="34" charset="0"/>
+              </a:endParaRPr>
+            </a:p>
+          </p:txBody>
+        </p:sp>
+        <p:sp>
+          <p:nvSpPr>
+            <p:cNvPr id="50" name="Textbox 50">
+              <a:extLst>
+                <a:ext uri="{FF2B5EF4-FFF2-40B4-BE49-F238E27FC236}">
+                  <a16:creationId xmlns:a16="http://schemas.microsoft.com/office/drawing/2014/main" id="{E51E8DF1-3FA0-9D36-5635-30C9867CDEA7}"/>
+                </a:ext>
+              </a:extLst>
+            </p:cNvPr>
+            <p:cNvSpPr txBox="1"/>
+            <p:nvPr/>
+          </p:nvSpPr>
+          <p:spPr>
+            <a:xfrm>
+              <a:off x="46990" y="4958715"/>
+              <a:ext cx="2934970" cy="410209"/>
+            </a:xfrm>
+            <a:prstGeom prst="rect">
+              <a:avLst/>
+            </a:prstGeom>
+            <a:ln w="25400">
+              <a:solidFill>
+                <a:srgbClr val="4F81BB"/>
+              </a:solidFill>
+              <a:prstDash val="solid"/>
+            </a:ln>
+          </p:spPr>
+          <p:txBody>
+            <a:bodyPr wrap="square" lIns="0" tIns="0" rIns="0" bIns="0" rtlCol="0">
+              <a:noAutofit/>
+            </a:bodyPr>
+            <a:lstStyle/>
+            <a:p>
+              <a:pPr marR="5080" algn="ctr">
+                <a:spcBef>
+                  <a:spcPts val="395"/>
+                </a:spcBef>
+                <a:buNone/>
+              </a:pPr>
+              <a:r>
+                <a:rPr lang="en-US" sz="1050">
+                  <a:effectLst/>
+                  <a:latin typeface="Microsoft Sans Serif" panose="020B0604020202020204" pitchFamily="34" charset="0"/>
+                  <a:ea typeface="Microsoft Sans Serif" panose="020B0604020202020204" pitchFamily="34" charset="0"/>
+                </a:rPr>
+                <a:t>Data </a:t>
+              </a:r>
+              <a:r>
+                <a:rPr lang="en-US" sz="1050" spc="-10">
+                  <a:effectLst/>
+                  <a:latin typeface="Microsoft Sans Serif" panose="020B0604020202020204" pitchFamily="34" charset="0"/>
+                  <a:ea typeface="Microsoft Sans Serif" panose="020B0604020202020204" pitchFamily="34" charset="0"/>
+                </a:rPr>
+                <a:t>Modeling</a:t>
+              </a:r>
+              <a:endParaRPr lang="en-IN" sz="1050">
+                <a:effectLst/>
+                <a:latin typeface="Microsoft Sans Serif" panose="020B0604020202020204" pitchFamily="34" charset="0"/>
+                <a:ea typeface="Microsoft Sans Serif" panose="020B0604020202020204" pitchFamily="34" charset="0"/>
+              </a:endParaRPr>
+            </a:p>
+          </p:txBody>
+        </p:sp>
+      </p:grpSp>
+      <p:sp>
+        <p:nvSpPr>
+          <p:cNvPr id="51" name="Rectangle 44">
+            <a:extLst>
+              <a:ext uri="{FF2B5EF4-FFF2-40B4-BE49-F238E27FC236}">
+                <a16:creationId xmlns:a16="http://schemas.microsoft.com/office/drawing/2014/main" id="{F7FFD6A2-B544-BE31-1011-8DAC215EECA5}"/>
+              </a:ext>
+            </a:extLst>
+          </p:cNvPr>
+          <p:cNvSpPr>
+            <a:spLocks noChangeArrowheads="1"/>
+          </p:cNvSpPr>
+          <p:nvPr/>
+        </p:nvSpPr>
+        <p:spPr bwMode="auto">
+          <a:xfrm>
+            <a:off x="2996856" y="-2213293"/>
+            <a:ext cx="339781" cy="1061829"/>
+          </a:xfrm>
+          <a:prstGeom prst="rect">
+            <a:avLst/>
+          </a:prstGeom>
+          <a:noFill/>
+          <a:ln>
+            <a:noFill/>
+          </a:ln>
+          <a:effectLst/>
+          <a:extLst>
+            <a:ext uri="{909E8E84-426E-40DD-AFC4-6F175D3DCCD1}">
+              <a14:hiddenFill xmlns:a14="http://schemas.microsoft.com/office/drawing/2010/main">
+                <a:solidFill>
+                  <a:schemeClr val="accent1"/>
+                </a:solidFill>
+              </a14:hiddenFill>
+            </a:ext>
+            <a:ext uri="{91240B29-F687-4F45-9708-019B960494DF}">
+              <a14:hiddenLine xmlns:a14="http://schemas.microsoft.com/office/drawing/2010/main" w="9525">
+                <a:solidFill>
+                  <a:schemeClr val="tx1"/>
+                </a:solidFill>
+                <a:miter lim="800000"/>
+                <a:headEnd/>
+                <a:tailEnd/>
+              </a14:hiddenLine>
+            </a:ext>
+            <a:ext uri="{AF507438-7753-43E0-B8FC-AC1667EBCBE1}">
+              <a14:hiddenEffects xmlns:a14="http://schemas.microsoft.com/office/drawing/2010/main">
+                <a:effectLst>
+                  <a:outerShdw dist="35921" dir="2700000" algn="ctr" rotWithShape="0">
+                    <a:schemeClr val="bg2"/>
+                  </a:outerShdw>
+                </a:effectLst>
+              </a14:hiddenEffects>
+            </a:ext>
+          </a:extLst>
+        </p:spPr>
+        <p:txBody>
+          <a:bodyPr vert="horz" wrap="square" lIns="91440" tIns="45720" rIns="91440" bIns="45720" numCol="1" anchor="ctr" anchorCtr="0" compatLnSpc="1">
+            <a:prstTxWarp prst="textNoShape">
+              <a:avLst/>
+            </a:prstTxWarp>
+            <a:spAutoFit/>
+          </a:bodyPr>
+          <a:lstStyle/>
+          <a:p>
+            <a:pPr marL="0" marR="0" lvl="0" indent="0" algn="l" defTabSz="914400" rtl="0" eaLnBrk="0" fontAlgn="base" latinLnBrk="0" hangingPunct="0">
+              <a:lnSpc>
+                <a:spcPct val="100000"/>
+              </a:lnSpc>
+              <a:spcBef>
+                <a:spcPct val="0"/>
+              </a:spcBef>
+              <a:spcAft>
+                <a:spcPct val="0"/>
+              </a:spcAft>
+              <a:buClrTx/>
+              <a:buSzTx/>
+              <a:buFontTx/>
+              <a:buNone/>
+              <a:tabLst/>
+            </a:pPr>
+            <a:endParaRPr kumimoji="0" lang="en-US" altLang="en-US" sz="1050" b="0" i="0" u="none" strike="noStrike" cap="none" normalizeH="0" baseline="0">
+              <a:ln>
+                <a:noFill/>
+              </a:ln>
+              <a:solidFill>
+                <a:schemeClr val="tx1"/>
+              </a:solidFill>
+              <a:effectLst/>
+              <a:latin typeface="Calibri" panose="020F0502020204030204" pitchFamily="34" charset="0"/>
+              <a:ea typeface="Microsoft Sans Serif" panose="020B0604020202020204" pitchFamily="34" charset="0"/>
+              <a:cs typeface="Calibri" panose="020F0502020204030204" pitchFamily="34" charset="0"/>
+            </a:endParaRPr>
+          </a:p>
+          <a:p>
+            <a:pPr marL="0" marR="0" lvl="0" indent="0" algn="l" defTabSz="914400" rtl="0" eaLnBrk="0" fontAlgn="base" latinLnBrk="0" hangingPunct="0">
+              <a:lnSpc>
+                <a:spcPct val="100000"/>
+              </a:lnSpc>
+              <a:spcBef>
+                <a:spcPct val="0"/>
+              </a:spcBef>
+              <a:spcAft>
+                <a:spcPct val="0"/>
+              </a:spcAft>
+              <a:buClrTx/>
+              <a:buSzTx/>
+              <a:buFontTx/>
+              <a:buNone/>
+              <a:tabLst/>
+            </a:pPr>
+            <a:r>
+              <a:rPr kumimoji="0" lang="en-US" altLang="en-US" sz="1050" b="0" i="0" u="none" strike="noStrike" cap="none" normalizeH="0" baseline="0">
+                <a:ln>
+                  <a:noFill/>
+                </a:ln>
+                <a:solidFill>
+                  <a:schemeClr val="tx1"/>
+                </a:solidFill>
+                <a:effectLst/>
+                <a:latin typeface="Calibri" panose="020F0502020204030204" pitchFamily="34" charset="0"/>
+                <a:ea typeface="Microsoft Sans Serif" panose="020B0604020202020204" pitchFamily="34" charset="0"/>
+                <a:cs typeface="Calibri" panose="020F0502020204030204" pitchFamily="34" charset="0"/>
+              </a:rPr>
+              <a:t>pg. 30</a:t>
+            </a:r>
+          </a:p>
+          <a:p>
+            <a:pPr marL="0" marR="0" lvl="0" indent="0" algn="l" defTabSz="914400" rtl="0" eaLnBrk="0" fontAlgn="base" latinLnBrk="0" hangingPunct="0">
+              <a:lnSpc>
+                <a:spcPct val="100000"/>
+              </a:lnSpc>
+              <a:spcBef>
+                <a:spcPct val="0"/>
+              </a:spcBef>
+              <a:spcAft>
+                <a:spcPct val="0"/>
+              </a:spcAft>
+              <a:buClrTx/>
+              <a:buSzTx/>
+              <a:buFontTx/>
+              <a:buNone/>
+              <a:tabLst/>
+            </a:pPr>
+            <a:br>
+              <a:rPr kumimoji="0" lang="en-US" altLang="en-US" sz="1050" b="0" i="0" u="none" strike="noStrike" cap="none" normalizeH="0" baseline="0">
+                <a:ln>
+                  <a:noFill/>
+                </a:ln>
+                <a:solidFill>
+                  <a:schemeClr val="tx1"/>
+                </a:solidFill>
+                <a:effectLst/>
+                <a:latin typeface="Calibri" panose="020F0502020204030204" pitchFamily="34" charset="0"/>
+                <a:ea typeface="Microsoft Sans Serif" panose="020B0604020202020204" pitchFamily="34" charset="0"/>
+                <a:cs typeface="Calibri" panose="020F0502020204030204" pitchFamily="34" charset="0"/>
+              </a:rPr>
+            </a:br>
+            <a:endParaRPr kumimoji="0" lang="en-US" altLang="en-US" sz="1050" b="0" i="0" u="none" strike="noStrike" cap="none" normalizeH="0" baseline="0">
+              <a:ln>
+                <a:noFill/>
+              </a:ln>
+              <a:solidFill>
+                <a:schemeClr val="tx1"/>
+              </a:solidFill>
+              <a:effectLst/>
+              <a:latin typeface="Arial" panose="020B0604020202020204" pitchFamily="34" charset="0"/>
+            </a:endParaRPr>
           </a:p>
         </p:txBody>
       </p:sp>
@@ -7609,7 +9777,7 @@
         <p:spPr>
           <a:xfrm>
             <a:off x="914398" y="1874519"/>
-            <a:ext cx="4824000" cy="3231654"/>
+            <a:ext cx="4824000" cy="3046988"/>
           </a:xfrm>
           <a:prstGeom prst="rect">
             <a:avLst/>
@@ -7628,17 +9796,7 @@
             </a:pPr>
             <a:r>
               <a:rPr lang="en-IN" sz="1200" dirty="0"/>
-              <a:t>  </a:t>
-            </a:r>
-          </a:p>
-          <a:p>
-            <a:pPr marL="171450" indent="-171450">
-              <a:buFont typeface="Arial" panose="020B0604020202020204" pitchFamily="34" charset="0"/>
-              <a:buChar char="•"/>
-            </a:pPr>
-            <a:r>
-              <a:rPr lang="en-IN" sz="1200" dirty="0"/>
-              <a:t>We sincerely thank the Infosys Springboard Team for providing this enriching virtual internship and a structured platform for gaining practical industry experience.</a:t>
+              <a:t>  We sincerely thank the Infosys Springboard Team for providing this enriching virtual internship and a structured platform for gaining practical industry experience.</a:t>
             </a:r>
           </a:p>
           <a:p>

</xml_diff>